<commit_message>
Reorganize Business Analytics course materials for 2026
</commit_message>
<xml_diff>
--- a/02_Slides/Day 3 - Creating Business Value through Data Presentation.pptx
+++ b/02_Slides/Day 3 - Creating Business Value through Data Presentation.pptx
@@ -5,7 +5,7 @@
     <p:sldMasterId id="2147483648" r:id="rId1"/>
   </p:sldMasterIdLst>
   <p:notesMasterIdLst>
-    <p:notesMasterId r:id="rId27"/>
+    <p:notesMasterId r:id="rId32"/>
   </p:notesMasterIdLst>
   <p:sldIdLst>
     <p:sldId id="256" r:id="rId2"/>
@@ -16,54 +16,59 @@
     <p:sldId id="261" r:id="rId7"/>
     <p:sldId id="262" r:id="rId8"/>
     <p:sldId id="268" r:id="rId9"/>
-    <p:sldId id="263" r:id="rId10"/>
-    <p:sldId id="264" r:id="rId11"/>
-    <p:sldId id="265" r:id="rId12"/>
-    <p:sldId id="269" r:id="rId13"/>
-    <p:sldId id="270" r:id="rId14"/>
-    <p:sldId id="271" r:id="rId15"/>
-    <p:sldId id="272" r:id="rId16"/>
-    <p:sldId id="277" r:id="rId17"/>
-    <p:sldId id="273" r:id="rId18"/>
-    <p:sldId id="274" r:id="rId19"/>
-    <p:sldId id="275" r:id="rId20"/>
-    <p:sldId id="276" r:id="rId21"/>
-    <p:sldId id="266" r:id="rId22"/>
-    <p:sldId id="278" r:id="rId23"/>
-    <p:sldId id="280" r:id="rId24"/>
-    <p:sldId id="279" r:id="rId25"/>
-    <p:sldId id="267" r:id="rId26"/>
+    <p:sldId id="283" r:id="rId10"/>
+    <p:sldId id="287" r:id="rId11"/>
+    <p:sldId id="282" r:id="rId12"/>
+    <p:sldId id="263" r:id="rId13"/>
+    <p:sldId id="264" r:id="rId14"/>
+    <p:sldId id="265" r:id="rId15"/>
+    <p:sldId id="269" r:id="rId16"/>
+    <p:sldId id="270" r:id="rId17"/>
+    <p:sldId id="271" r:id="rId18"/>
+    <p:sldId id="272" r:id="rId19"/>
+    <p:sldId id="277" r:id="rId20"/>
+    <p:sldId id="273" r:id="rId21"/>
+    <p:sldId id="274" r:id="rId22"/>
+    <p:sldId id="275" r:id="rId23"/>
+    <p:sldId id="276" r:id="rId24"/>
+    <p:sldId id="281" r:id="rId25"/>
+    <p:sldId id="266" r:id="rId26"/>
+    <p:sldId id="278" r:id="rId27"/>
+    <p:sldId id="285" r:id="rId28"/>
+    <p:sldId id="279" r:id="rId29"/>
+    <p:sldId id="286" r:id="rId30"/>
+    <p:sldId id="267" r:id="rId31"/>
   </p:sldIdLst>
   <p:sldSz cx="9144000" cy="6858000" type="screen4x3"/>
   <p:notesSz cx="6858000" cy="9144000"/>
   <p:embeddedFontLst>
     <p:embeddedFont>
       <p:font typeface="Calibri" panose="020F0502020204030204" pitchFamily="34" charset="0"/>
-      <p:regular r:id="rId28"/>
-      <p:bold r:id="rId29"/>
-      <p:italic r:id="rId30"/>
-      <p:boldItalic r:id="rId31"/>
+      <p:regular r:id="rId33"/>
+      <p:bold r:id="rId34"/>
+      <p:italic r:id="rId35"/>
+      <p:boldItalic r:id="rId36"/>
     </p:embeddedFont>
     <p:embeddedFont>
       <p:font typeface="Economica" panose="02000506040000020004" pitchFamily="2" charset="77"/>
-      <p:regular r:id="rId32"/>
-      <p:bold r:id="rId33"/>
-      <p:italic r:id="rId34"/>
-      <p:boldItalic r:id="rId35"/>
+      <p:regular r:id="rId37"/>
+      <p:bold r:id="rId38"/>
+      <p:italic r:id="rId39"/>
+      <p:boldItalic r:id="rId40"/>
     </p:embeddedFont>
     <p:embeddedFont>
       <p:font typeface="Open Sans" panose="020B0606030504020204" pitchFamily="34" charset="0"/>
-      <p:regular r:id="rId36"/>
-      <p:bold r:id="rId37"/>
-      <p:italic r:id="rId38"/>
-      <p:boldItalic r:id="rId39"/>
+      <p:regular r:id="rId41"/>
+      <p:bold r:id="rId42"/>
+      <p:italic r:id="rId43"/>
+      <p:boldItalic r:id="rId44"/>
     </p:embeddedFont>
     <p:embeddedFont>
       <p:font typeface="Verdana" panose="020B0604030504040204" pitchFamily="34" charset="0"/>
-      <p:regular r:id="rId40"/>
-      <p:bold r:id="rId41"/>
-      <p:italic r:id="rId42"/>
-      <p:boldItalic r:id="rId43"/>
+      <p:regular r:id="rId45"/>
+      <p:bold r:id="rId46"/>
+      <p:italic r:id="rId47"/>
+      <p:boldItalic r:id="rId48"/>
     </p:embeddedFont>
   </p:embeddedFontLst>
   <p:defaultTextStyle>
@@ -300,7 +305,7 @@
       <p15:sldGuideLst xmlns:p15="http://schemas.microsoft.com/office/powerpoint/2012/main"/>
     </p:ext>
     <p:ext uri="http://customooxmlschemas.google.com/">
-      <go:slidesCustomData xmlns:go="http://customooxmlschemas.google.com/" xmlns:ahyp="http://schemas.microsoft.com/office/drawing/2018/hyperlinkcolor" xmlns:p15="http://schemas.microsoft.com/office/powerpoint/2012/main" xmlns:p14="http://schemas.microsoft.com/office/powerpoint/2010/main" xmlns:com="http://schemas.openxmlformats.org/drawingml/2006/compatibility" xmlns:pvml="urn:schemas-microsoft-com:office:powerpoint" xmlns:v="urn:schemas-microsoft-com:vml" xmlns:o="urn:schemas-microsoft-com:office:office" xmlns:dgm="http://schemas.openxmlformats.org/drawingml/2006/diagram" xmlns:c="http://schemas.openxmlformats.org/drawingml/2006/chart" xmlns:mv="urn:schemas-microsoft-com:mac:vml" xmlns:mc="http://schemas.openxmlformats.org/markup-compatibility/2006" xmlns="" r:id="rId45" roundtripDataSignature="AMtx7mhCkFchV/Y3T266NQYkEP6CQ6cfag=="/>
+      <go:slidesCustomData xmlns="" xmlns:mc="http://schemas.openxmlformats.org/markup-compatibility/2006" xmlns:mv="urn:schemas-microsoft-com:mac:vml" xmlns:c="http://schemas.openxmlformats.org/drawingml/2006/chart" xmlns:dgm="http://schemas.openxmlformats.org/drawingml/2006/diagram" xmlns:o="urn:schemas-microsoft-com:office:office" xmlns:v="urn:schemas-microsoft-com:vml" xmlns:pvml="urn:schemas-microsoft-com:office:powerpoint" xmlns:com="http://schemas.openxmlformats.org/drawingml/2006/compatibility" xmlns:p14="http://schemas.microsoft.com/office/powerpoint/2010/main" xmlns:p15="http://schemas.microsoft.com/office/powerpoint/2012/main" xmlns:ahyp="http://schemas.microsoft.com/office/drawing/2018/hyperlinkcolor" xmlns:go="http://customooxmlschemas.google.com/" r:id="rId49" roundtripDataSignature="AMtx7mhCkFchV/Y3T266NQYkEP6CQ6cfag=="/>
     </p:ext>
   </p:extLst>
 </p:presentation>
@@ -5923,7 +5928,7 @@
         </a:prstGeom>
         <a:solidFill>
           <a:schemeClr val="accent5">
-            <a:hueOff val="-1721579"/>
+            <a:hueOff val="-1721578"/>
             <a:satOff val="10962"/>
             <a:lumOff val="2745"/>
             <a:alphaOff val="0"/>
@@ -6077,7 +6082,7 @@
         </a:prstGeom>
         <a:solidFill>
           <a:schemeClr val="accent5">
-            <a:hueOff val="-5164736"/>
+            <a:hueOff val="-5164735"/>
             <a:satOff val="32886"/>
             <a:lumOff val="8235"/>
             <a:alphaOff val="0"/>
@@ -15852,7 +15857,7 @@
             </a:pPr>
             <a:fld id="{00000000-1234-1234-1234-123412341234}" type="slidenum">
               <a:rPr lang="en-US"/>
-              <a:t>11</a:t>
+              <a:t>14</a:t>
             </a:fld>
             <a:endParaRPr/>
           </a:p>
@@ -16014,7 +16019,7 @@
                 <a:cs typeface="Calibri"/>
                 <a:sym typeface="Calibri"/>
               </a:rPr>
-              <a:t>14</a:t>
+              <a:t>17</a:t>
             </a:fld>
             <a:endParaRPr lang="en-US" sz="1200" b="0" i="0" u="none" strike="noStrike" cap="none">
               <a:solidFill>
@@ -16131,7 +16136,7 @@
                 <a:cs typeface="Calibri"/>
                 <a:sym typeface="Calibri"/>
               </a:rPr>
-              <a:t>19</a:t>
+              <a:t>22</a:t>
             </a:fld>
             <a:endParaRPr lang="en-US" sz="1200" b="0" i="0" u="none" strike="noStrike" cap="none">
               <a:solidFill>
@@ -16281,6 +16286,402 @@
 </file>
 
 <file path=ppt/notesSlides/notesSlide14.xml><?xml version="1.0" encoding="utf-8"?>
+<p:notes xmlns:a="http://schemas.openxmlformats.org/drawingml/2006/main" xmlns:r="http://schemas.openxmlformats.org/officeDocument/2006/relationships" xmlns:p="http://schemas.openxmlformats.org/presentationml/2006/main">
+  <p:cSld>
+    <p:spTree>
+      <p:nvGrpSpPr>
+        <p:cNvPr id="1" name=""/>
+        <p:cNvGrpSpPr/>
+        <p:nvPr/>
+      </p:nvGrpSpPr>
+      <p:grpSpPr>
+        <a:xfrm>
+          <a:off x="0" y="0"/>
+          <a:ext cx="0" cy="0"/>
+          <a:chOff x="0" y="0"/>
+          <a:chExt cx="0" cy="0"/>
+        </a:xfrm>
+      </p:grpSpPr>
+      <p:sp>
+        <p:nvSpPr>
+          <p:cNvPr id="2" name="Slide Image Placeholder 1"/>
+          <p:cNvSpPr>
+            <a:spLocks noGrp="1" noRot="1" noChangeAspect="1"/>
+          </p:cNvSpPr>
+          <p:nvPr>
+            <p:ph type="sldImg"/>
+          </p:nvPr>
+        </p:nvSpPr>
+        <p:spPr/>
+      </p:sp>
+      <p:sp>
+        <p:nvSpPr>
+          <p:cNvPr id="3" name="Notes Placeholder 2"/>
+          <p:cNvSpPr>
+            <a:spLocks noGrp="1"/>
+          </p:cNvSpPr>
+          <p:nvPr>
+            <p:ph type="body" idx="1"/>
+          </p:nvPr>
+        </p:nvSpPr>
+        <p:spPr/>
+        <p:txBody>
+          <a:bodyPr/>
+          <a:lstStyle/>
+          <a:p>
+            <a:endParaRPr lang="en-US" dirty="0"/>
+          </a:p>
+        </p:txBody>
+      </p:sp>
+      <p:sp>
+        <p:nvSpPr>
+          <p:cNvPr id="4" name="Slide Number Placeholder 3"/>
+          <p:cNvSpPr>
+            <a:spLocks noGrp="1"/>
+          </p:cNvSpPr>
+          <p:nvPr>
+            <p:ph type="sldNum" idx="12"/>
+          </p:nvPr>
+        </p:nvSpPr>
+        <p:spPr/>
+        <p:txBody>
+          <a:bodyPr/>
+          <a:lstStyle/>
+          <a:p>
+            <a:pPr marL="0" marR="0" lvl="0" indent="0" algn="r" rtl="0">
+              <a:lnSpc>
+                <a:spcPct val="100000"/>
+              </a:lnSpc>
+              <a:spcBef>
+                <a:spcPts val="0"/>
+              </a:spcBef>
+              <a:spcAft>
+                <a:spcPts val="0"/>
+              </a:spcAft>
+              <a:buClr>
+                <a:srgbClr val="000000"/>
+              </a:buClr>
+              <a:buSzPts val="1200"/>
+              <a:buFont typeface="Arial"/>
+              <a:buNone/>
+            </a:pPr>
+            <a:fld id="{00000000-1234-1234-1234-123412341234}" type="slidenum">
+              <a:rPr lang="en-US" sz="1200" b="0" i="0" u="none" strike="noStrike" cap="none" smtClean="0">
+                <a:solidFill>
+                  <a:schemeClr val="dk1"/>
+                </a:solidFill>
+                <a:latin typeface="Calibri"/>
+                <a:ea typeface="Calibri"/>
+                <a:cs typeface="Calibri"/>
+                <a:sym typeface="Calibri"/>
+              </a:rPr>
+              <a:t>26</a:t>
+            </a:fld>
+            <a:endParaRPr lang="en-US" sz="1200" b="0" i="0" u="none" strike="noStrike" cap="none">
+              <a:solidFill>
+                <a:schemeClr val="dk1"/>
+              </a:solidFill>
+              <a:latin typeface="Calibri"/>
+              <a:ea typeface="Calibri"/>
+              <a:cs typeface="Calibri"/>
+              <a:sym typeface="Calibri"/>
+            </a:endParaRPr>
+          </a:p>
+        </p:txBody>
+      </p:sp>
+    </p:spTree>
+    <p:extLst>
+      <p:ext uri="{BB962C8B-B14F-4D97-AF65-F5344CB8AC3E}">
+        <p14:creationId xmlns:p14="http://schemas.microsoft.com/office/powerpoint/2010/main" val="2394428637"/>
+      </p:ext>
+    </p:extLst>
+  </p:cSld>
+  <p:clrMapOvr>
+    <a:masterClrMapping/>
+  </p:clrMapOvr>
+</p:notes>
+</file>
+
+<file path=ppt/notesSlides/notesSlide15.xml><?xml version="1.0" encoding="utf-8"?>
+<p:notes xmlns:a="http://schemas.openxmlformats.org/drawingml/2006/main" xmlns:r="http://schemas.openxmlformats.org/officeDocument/2006/relationships" xmlns:p="http://schemas.openxmlformats.org/presentationml/2006/main">
+  <p:cSld>
+    <p:spTree>
+      <p:nvGrpSpPr>
+        <p:cNvPr id="1" name=""/>
+        <p:cNvGrpSpPr/>
+        <p:nvPr/>
+      </p:nvGrpSpPr>
+      <p:grpSpPr>
+        <a:xfrm>
+          <a:off x="0" y="0"/>
+          <a:ext cx="0" cy="0"/>
+          <a:chOff x="0" y="0"/>
+          <a:chExt cx="0" cy="0"/>
+        </a:xfrm>
+      </p:grpSpPr>
+      <p:sp>
+        <p:nvSpPr>
+          <p:cNvPr id="2" name="Slide Image Placeholder 1"/>
+          <p:cNvSpPr>
+            <a:spLocks noGrp="1" noRot="1" noChangeAspect="1"/>
+          </p:cNvSpPr>
+          <p:nvPr>
+            <p:ph type="sldImg"/>
+          </p:nvPr>
+        </p:nvSpPr>
+        <p:spPr/>
+      </p:sp>
+      <p:sp>
+        <p:nvSpPr>
+          <p:cNvPr id="3" name="Notes Placeholder 2"/>
+          <p:cNvSpPr>
+            <a:spLocks noGrp="1"/>
+          </p:cNvSpPr>
+          <p:nvPr>
+            <p:ph type="body" idx="1"/>
+          </p:nvPr>
+        </p:nvSpPr>
+        <p:spPr/>
+        <p:txBody>
+          <a:bodyPr/>
+          <a:lstStyle/>
+          <a:p>
+            <a:r>
+              <a:rPr lang="en-US" dirty="0">
+                <a:hlinkClick r:id="rId3"/>
+              </a:rPr>
+              <a:t>https://www.flutura.com/resources/articles/upstream-sensor-data-big-data-analytics-game-changer-in-oil-n-gas-industry</a:t>
+            </a:r>
+            <a:endParaRPr lang="en-US" dirty="0"/>
+          </a:p>
+          <a:p>
+            <a:r>
+              <a:rPr lang="en-US" dirty="0">
+                <a:hlinkClick r:id="rId4"/>
+              </a:rPr>
+              <a:t>https://databricks.com/blog/2021/04/08/efficiently-building-ml-models-for-predictive-maintenance-in-the-oil-and-gas-industry-with-databricks.html</a:t>
+            </a:r>
+            <a:endParaRPr lang="en-US" dirty="0"/>
+          </a:p>
+          <a:p>
+            <a:endParaRPr lang="en-US" dirty="0"/>
+          </a:p>
+        </p:txBody>
+      </p:sp>
+      <p:sp>
+        <p:nvSpPr>
+          <p:cNvPr id="4" name="Slide Number Placeholder 3"/>
+          <p:cNvSpPr>
+            <a:spLocks noGrp="1"/>
+          </p:cNvSpPr>
+          <p:nvPr>
+            <p:ph type="sldNum" idx="12"/>
+          </p:nvPr>
+        </p:nvSpPr>
+        <p:spPr/>
+        <p:txBody>
+          <a:bodyPr/>
+          <a:lstStyle/>
+          <a:p>
+            <a:pPr marL="0" marR="0" lvl="0" indent="0" algn="r" rtl="0">
+              <a:lnSpc>
+                <a:spcPct val="100000"/>
+              </a:lnSpc>
+              <a:spcBef>
+                <a:spcPts val="0"/>
+              </a:spcBef>
+              <a:spcAft>
+                <a:spcPts val="0"/>
+              </a:spcAft>
+              <a:buClr>
+                <a:srgbClr val="000000"/>
+              </a:buClr>
+              <a:buSzPts val="1200"/>
+              <a:buFont typeface="Arial"/>
+              <a:buNone/>
+            </a:pPr>
+            <a:fld id="{00000000-1234-1234-1234-123412341234}" type="slidenum">
+              <a:rPr lang="en-US" sz="1200" b="0" i="0" u="none" strike="noStrike" cap="none" smtClean="0">
+                <a:solidFill>
+                  <a:schemeClr val="dk1"/>
+                </a:solidFill>
+                <a:latin typeface="Calibri"/>
+                <a:ea typeface="Calibri"/>
+                <a:cs typeface="Calibri"/>
+                <a:sym typeface="Calibri"/>
+              </a:rPr>
+              <a:t>27</a:t>
+            </a:fld>
+            <a:endParaRPr lang="en-US" sz="1200" b="0" i="0" u="none" strike="noStrike" cap="none">
+              <a:solidFill>
+                <a:schemeClr val="dk1"/>
+              </a:solidFill>
+              <a:latin typeface="Calibri"/>
+              <a:ea typeface="Calibri"/>
+              <a:cs typeface="Calibri"/>
+              <a:sym typeface="Calibri"/>
+            </a:endParaRPr>
+          </a:p>
+        </p:txBody>
+      </p:sp>
+    </p:spTree>
+    <p:extLst>
+      <p:ext uri="{BB962C8B-B14F-4D97-AF65-F5344CB8AC3E}">
+        <p14:creationId xmlns:p14="http://schemas.microsoft.com/office/powerpoint/2010/main" val="2640223347"/>
+      </p:ext>
+    </p:extLst>
+  </p:cSld>
+  <p:clrMapOvr>
+    <a:masterClrMapping/>
+  </p:clrMapOvr>
+</p:notes>
+</file>
+
+<file path=ppt/notesSlides/notesSlide16.xml><?xml version="1.0" encoding="utf-8"?>
+<p:notes xmlns:a="http://schemas.openxmlformats.org/drawingml/2006/main" xmlns:r="http://schemas.openxmlformats.org/officeDocument/2006/relationships" xmlns:p="http://schemas.openxmlformats.org/presentationml/2006/main">
+  <p:cSld>
+    <p:spTree>
+      <p:nvGrpSpPr>
+        <p:cNvPr id="1" name=""/>
+        <p:cNvGrpSpPr/>
+        <p:nvPr/>
+      </p:nvGrpSpPr>
+      <p:grpSpPr>
+        <a:xfrm>
+          <a:off x="0" y="0"/>
+          <a:ext cx="0" cy="0"/>
+          <a:chOff x="0" y="0"/>
+          <a:chExt cx="0" cy="0"/>
+        </a:xfrm>
+      </p:grpSpPr>
+      <p:sp>
+        <p:nvSpPr>
+          <p:cNvPr id="2" name="Slide Image Placeholder 1"/>
+          <p:cNvSpPr>
+            <a:spLocks noGrp="1" noRot="1" noChangeAspect="1"/>
+          </p:cNvSpPr>
+          <p:nvPr>
+            <p:ph type="sldImg"/>
+          </p:nvPr>
+        </p:nvSpPr>
+        <p:spPr/>
+      </p:sp>
+      <p:sp>
+        <p:nvSpPr>
+          <p:cNvPr id="3" name="Notes Placeholder 2"/>
+          <p:cNvSpPr>
+            <a:spLocks noGrp="1"/>
+          </p:cNvSpPr>
+          <p:nvPr>
+            <p:ph type="body" idx="1"/>
+          </p:nvPr>
+        </p:nvSpPr>
+        <p:spPr/>
+        <p:txBody>
+          <a:bodyPr/>
+          <a:lstStyle/>
+          <a:p>
+            <a:r>
+              <a:rPr lang="en-US" dirty="0"/>
+              <a:t>https://</a:t>
+            </a:r>
+            <a:r>
+              <a:rPr lang="en-US" dirty="0" err="1"/>
+              <a:t>public.tableau.com</a:t>
+            </a:r>
+            <a:r>
+              <a:rPr lang="en-US" dirty="0"/>
+              <a:t>/app/profile/</a:t>
+            </a:r>
+            <a:r>
+              <a:rPr lang="en-US" dirty="0" err="1"/>
+              <a:t>pajo</a:t>
+            </a:r>
+            <a:r>
+              <a:rPr lang="en-US" dirty="0"/>
+              <a:t>/viz/</a:t>
+            </a:r>
+            <a:r>
+              <a:rPr lang="en-US" dirty="0" err="1"/>
+              <a:t>Kutch_OilSPil</a:t>
+            </a:r>
+            <a:r>
+              <a:rPr lang="en-US" dirty="0"/>
+              <a:t>/Dashboard1</a:t>
+            </a:r>
+          </a:p>
+        </p:txBody>
+      </p:sp>
+      <p:sp>
+        <p:nvSpPr>
+          <p:cNvPr id="4" name="Slide Number Placeholder 3"/>
+          <p:cNvSpPr>
+            <a:spLocks noGrp="1"/>
+          </p:cNvSpPr>
+          <p:nvPr>
+            <p:ph type="sldNum" idx="12"/>
+          </p:nvPr>
+        </p:nvSpPr>
+        <p:spPr/>
+        <p:txBody>
+          <a:bodyPr/>
+          <a:lstStyle/>
+          <a:p>
+            <a:pPr marL="0" marR="0" lvl="0" indent="0" algn="r" rtl="0">
+              <a:lnSpc>
+                <a:spcPct val="100000"/>
+              </a:lnSpc>
+              <a:spcBef>
+                <a:spcPts val="0"/>
+              </a:spcBef>
+              <a:spcAft>
+                <a:spcPts val="0"/>
+              </a:spcAft>
+              <a:buClr>
+                <a:srgbClr val="000000"/>
+              </a:buClr>
+              <a:buSzPts val="1200"/>
+              <a:buFont typeface="Arial"/>
+              <a:buNone/>
+            </a:pPr>
+            <a:fld id="{00000000-1234-1234-1234-123412341234}" type="slidenum">
+              <a:rPr lang="en-US" sz="1200" b="0" i="0" u="none" strike="noStrike" cap="none" smtClean="0">
+                <a:solidFill>
+                  <a:schemeClr val="dk1"/>
+                </a:solidFill>
+                <a:latin typeface="Calibri"/>
+                <a:ea typeface="Calibri"/>
+                <a:cs typeface="Calibri"/>
+                <a:sym typeface="Calibri"/>
+              </a:rPr>
+              <a:t>29</a:t>
+            </a:fld>
+            <a:endParaRPr lang="en-US" sz="1200" b="0" i="0" u="none" strike="noStrike" cap="none">
+              <a:solidFill>
+                <a:schemeClr val="dk1"/>
+              </a:solidFill>
+              <a:latin typeface="Calibri"/>
+              <a:ea typeface="Calibri"/>
+              <a:cs typeface="Calibri"/>
+              <a:sym typeface="Calibri"/>
+            </a:endParaRPr>
+          </a:p>
+        </p:txBody>
+      </p:sp>
+    </p:spTree>
+    <p:extLst>
+      <p:ext uri="{BB962C8B-B14F-4D97-AF65-F5344CB8AC3E}">
+        <p14:creationId xmlns:p14="http://schemas.microsoft.com/office/powerpoint/2010/main" val="3074635412"/>
+      </p:ext>
+    </p:extLst>
+  </p:cSld>
+  <p:clrMapOvr>
+    <a:masterClrMapping/>
+  </p:clrMapOvr>
+</p:notes>
+</file>
+
+<file path=ppt/notesSlides/notesSlide17.xml><?xml version="1.0" encoding="utf-8"?>
 <p:notes xmlns:a="http://schemas.openxmlformats.org/drawingml/2006/main" xmlns:r="http://schemas.openxmlformats.org/officeDocument/2006/relationships" xmlns:p="http://schemas.openxmlformats.org/presentationml/2006/main" showMasterSp="0" showMasterPhAnim="0">
   <p:cSld>
     <p:spTree>
@@ -17271,7 +17672,7 @@
             </a:pPr>
             <a:fld id="{00000000-1234-1234-1234-123412341234}" type="slidenum">
               <a:rPr lang="en-US"/>
-              <a:t>9</a:t>
+              <a:t>12</a:t>
             </a:fld>
             <a:endParaRPr/>
           </a:p>
@@ -17417,7 +17818,7 @@
             </a:pPr>
             <a:fld id="{00000000-1234-1234-1234-123412341234}" type="slidenum">
               <a:rPr lang="en-US"/>
-              <a:t>10</a:t>
+              <a:t>13</a:t>
             </a:fld>
             <a:endParaRPr/>
           </a:p>
@@ -26151,6 +26552,581 @@
   <p:cSld>
     <p:spTree>
       <p:nvGrpSpPr>
+        <p:cNvPr id="1" name=""/>
+        <p:cNvGrpSpPr/>
+        <p:nvPr/>
+      </p:nvGrpSpPr>
+      <p:grpSpPr>
+        <a:xfrm>
+          <a:off x="0" y="0"/>
+          <a:ext cx="0" cy="0"/>
+          <a:chOff x="0" y="0"/>
+          <a:chExt cx="0" cy="0"/>
+        </a:xfrm>
+      </p:grpSpPr>
+      <p:sp>
+        <p:nvSpPr>
+          <p:cNvPr id="2" name="Title 1">
+            <a:extLst>
+              <a:ext uri="{FF2B5EF4-FFF2-40B4-BE49-F238E27FC236}">
+                <a16:creationId xmlns:a16="http://schemas.microsoft.com/office/drawing/2014/main" id="{4EFA0410-2B5D-8874-D1C7-36145C3C81B7}"/>
+              </a:ext>
+            </a:extLst>
+          </p:cNvPr>
+          <p:cNvSpPr>
+            <a:spLocks noGrp="1"/>
+          </p:cNvSpPr>
+          <p:nvPr>
+            <p:ph type="title"/>
+          </p:nvPr>
+        </p:nvSpPr>
+        <p:spPr/>
+        <p:txBody>
+          <a:bodyPr/>
+          <a:lstStyle/>
+          <a:p>
+            <a:endParaRPr lang="en-US"/>
+          </a:p>
+        </p:txBody>
+      </p:sp>
+      <p:pic>
+        <p:nvPicPr>
+          <p:cNvPr id="5" name="Picture 4" descr="Graphical user interface&#10;&#10;Description automatically generated">
+            <a:extLst>
+              <a:ext uri="{FF2B5EF4-FFF2-40B4-BE49-F238E27FC236}">
+                <a16:creationId xmlns:a16="http://schemas.microsoft.com/office/drawing/2014/main" id="{5483288A-AD30-6929-9222-38F5FFD7E012}"/>
+              </a:ext>
+            </a:extLst>
+          </p:cNvPr>
+          <p:cNvPicPr>
+            <a:picLocks noChangeAspect="1"/>
+          </p:cNvPicPr>
+          <p:nvPr/>
+        </p:nvPicPr>
+        <p:blipFill>
+          <a:blip r:embed="rId2"/>
+          <a:stretch>
+            <a:fillRect/>
+          </a:stretch>
+        </p:blipFill>
+        <p:spPr>
+          <a:xfrm>
+            <a:off x="0" y="1221535"/>
+            <a:ext cx="9144000" cy="4414930"/>
+          </a:xfrm>
+          <a:prstGeom prst="rect">
+            <a:avLst/>
+          </a:prstGeom>
+        </p:spPr>
+      </p:pic>
+    </p:spTree>
+    <p:extLst>
+      <p:ext uri="{BB962C8B-B14F-4D97-AF65-F5344CB8AC3E}">
+        <p14:creationId xmlns:p14="http://schemas.microsoft.com/office/powerpoint/2010/main" val="553784901"/>
+      </p:ext>
+    </p:extLst>
+  </p:cSld>
+  <p:clrMapOvr>
+    <a:masterClrMapping/>
+  </p:clrMapOvr>
+</p:sld>
+</file>
+
+<file path=ppt/slides/slide11.xml><?xml version="1.0" encoding="utf-8"?>
+<p:sld xmlns:a="http://schemas.openxmlformats.org/drawingml/2006/main" xmlns:r="http://schemas.openxmlformats.org/officeDocument/2006/relationships" xmlns:p="http://schemas.openxmlformats.org/presentationml/2006/main">
+  <p:cSld>
+    <p:spTree>
+      <p:nvGrpSpPr>
+        <p:cNvPr id="1" name=""/>
+        <p:cNvGrpSpPr/>
+        <p:nvPr/>
+      </p:nvGrpSpPr>
+      <p:grpSpPr>
+        <a:xfrm>
+          <a:off x="0" y="0"/>
+          <a:ext cx="0" cy="0"/>
+          <a:chOff x="0" y="0"/>
+          <a:chExt cx="0" cy="0"/>
+        </a:xfrm>
+      </p:grpSpPr>
+      <p:sp>
+        <p:nvSpPr>
+          <p:cNvPr id="2" name="Title 1">
+            <a:extLst>
+              <a:ext uri="{FF2B5EF4-FFF2-40B4-BE49-F238E27FC236}">
+                <a16:creationId xmlns:a16="http://schemas.microsoft.com/office/drawing/2014/main" id="{6D0FEC0D-FBCE-C615-3C56-3C16A2CDD9A8}"/>
+              </a:ext>
+            </a:extLst>
+          </p:cNvPr>
+          <p:cNvSpPr>
+            <a:spLocks noGrp="1"/>
+          </p:cNvSpPr>
+          <p:nvPr>
+            <p:ph type="title"/>
+          </p:nvPr>
+        </p:nvSpPr>
+        <p:spPr/>
+        <p:txBody>
+          <a:bodyPr/>
+          <a:lstStyle/>
+          <a:p>
+            <a:r>
+              <a:rPr lang="en-US" dirty="0"/>
+              <a:t>ETL pipeline</a:t>
+            </a:r>
+          </a:p>
+        </p:txBody>
+      </p:sp>
+      <p:pic>
+        <p:nvPicPr>
+          <p:cNvPr id="5" name="Picture 4">
+            <a:extLst>
+              <a:ext uri="{FF2B5EF4-FFF2-40B4-BE49-F238E27FC236}">
+                <a16:creationId xmlns:a16="http://schemas.microsoft.com/office/drawing/2014/main" id="{228B676D-62A4-D028-13D0-86BEC5077FBE}"/>
+              </a:ext>
+            </a:extLst>
+          </p:cNvPr>
+          <p:cNvPicPr>
+            <a:picLocks noChangeAspect="1"/>
+          </p:cNvPicPr>
+          <p:nvPr/>
+        </p:nvPicPr>
+        <p:blipFill>
+          <a:blip r:embed="rId2"/>
+          <a:stretch>
+            <a:fillRect/>
+          </a:stretch>
+        </p:blipFill>
+        <p:spPr>
+          <a:xfrm>
+            <a:off x="453006" y="1157681"/>
+            <a:ext cx="3277464" cy="3959352"/>
+          </a:xfrm>
+          <a:prstGeom prst="rect">
+            <a:avLst/>
+          </a:prstGeom>
+        </p:spPr>
+      </p:pic>
+      <p:pic>
+        <p:nvPicPr>
+          <p:cNvPr id="1030" name="Picture 6">
+            <a:extLst>
+              <a:ext uri="{FF2B5EF4-FFF2-40B4-BE49-F238E27FC236}">
+                <a16:creationId xmlns:a16="http://schemas.microsoft.com/office/drawing/2014/main" id="{3666B208-3590-F7D5-C2E4-714884BA8E31}"/>
+              </a:ext>
+            </a:extLst>
+          </p:cNvPr>
+          <p:cNvPicPr>
+            <a:picLocks noChangeAspect="1" noChangeArrowheads="1"/>
+          </p:cNvPicPr>
+          <p:nvPr/>
+        </p:nvPicPr>
+        <p:blipFill>
+          <a:blip r:embed="rId3">
+            <a:extLst>
+              <a:ext uri="{28A0092B-C50C-407E-A947-70E740481C1C}">
+                <a14:useLocalDpi xmlns:a14="http://schemas.microsoft.com/office/drawing/2010/main" val="0"/>
+              </a:ext>
+            </a:extLst>
+          </a:blip>
+          <a:srcRect/>
+          <a:stretch>
+            <a:fillRect/>
+          </a:stretch>
+        </p:blipFill>
+        <p:spPr bwMode="auto">
+          <a:xfrm>
+            <a:off x="4005071" y="3429000"/>
+            <a:ext cx="4588263" cy="2633472"/>
+          </a:xfrm>
+          <a:prstGeom prst="rect">
+            <a:avLst/>
+          </a:prstGeom>
+          <a:noFill/>
+          <a:extLst>
+            <a:ext uri="{909E8E84-426E-40DD-AFC4-6F175D3DCCD1}">
+              <a14:hiddenFill xmlns:a14="http://schemas.microsoft.com/office/drawing/2010/main">
+                <a:solidFill>
+                  <a:srgbClr val="FFFFFF"/>
+                </a:solidFill>
+              </a14:hiddenFill>
+            </a:ext>
+          </a:extLst>
+        </p:spPr>
+      </p:pic>
+      <p:pic>
+        <p:nvPicPr>
+          <p:cNvPr id="8" name="Picture 7" descr="Graphical user interface, application&#10;&#10;Description automatically generated">
+            <a:extLst>
+              <a:ext uri="{FF2B5EF4-FFF2-40B4-BE49-F238E27FC236}">
+                <a16:creationId xmlns:a16="http://schemas.microsoft.com/office/drawing/2014/main" id="{8BB34A48-30DF-4F1B-7E6F-A139C1020A84}"/>
+              </a:ext>
+            </a:extLst>
+          </p:cNvPr>
+          <p:cNvPicPr>
+            <a:picLocks noChangeAspect="1"/>
+          </p:cNvPicPr>
+          <p:nvPr/>
+        </p:nvPicPr>
+        <p:blipFill>
+          <a:blip r:embed="rId4"/>
+          <a:stretch>
+            <a:fillRect/>
+          </a:stretch>
+        </p:blipFill>
+        <p:spPr>
+          <a:xfrm>
+            <a:off x="3879607" y="274320"/>
+            <a:ext cx="5067300" cy="3048000"/>
+          </a:xfrm>
+          <a:prstGeom prst="rect">
+            <a:avLst/>
+          </a:prstGeom>
+        </p:spPr>
+      </p:pic>
+    </p:spTree>
+    <p:extLst>
+      <p:ext uri="{BB962C8B-B14F-4D97-AF65-F5344CB8AC3E}">
+        <p14:creationId xmlns:p14="http://schemas.microsoft.com/office/powerpoint/2010/main" val="4028604874"/>
+      </p:ext>
+    </p:extLst>
+  </p:cSld>
+  <p:clrMapOvr>
+    <a:masterClrMapping/>
+  </p:clrMapOvr>
+</p:sld>
+</file>
+
+<file path=ppt/slides/slide12.xml><?xml version="1.0" encoding="utf-8"?>
+<p:sld xmlns:a="http://schemas.openxmlformats.org/drawingml/2006/main" xmlns:r="http://schemas.openxmlformats.org/officeDocument/2006/relationships" xmlns:p="http://schemas.openxmlformats.org/presentationml/2006/main">
+  <p:cSld>
+    <p:spTree>
+      <p:nvGrpSpPr>
+        <p:cNvPr id="1" name="Shape 109"/>
+        <p:cNvGrpSpPr/>
+        <p:nvPr/>
+      </p:nvGrpSpPr>
+      <p:grpSpPr>
+        <a:xfrm>
+          <a:off x="0" y="0"/>
+          <a:ext cx="0" cy="0"/>
+          <a:chOff x="0" y="0"/>
+          <a:chExt cx="0" cy="0"/>
+        </a:xfrm>
+      </p:grpSpPr>
+      <p:sp>
+        <p:nvSpPr>
+          <p:cNvPr id="110" name="Google Shape;110;g10a5157cc27_0_0"/>
+          <p:cNvSpPr txBox="1">
+            <a:spLocks noGrp="1"/>
+          </p:cNvSpPr>
+          <p:nvPr>
+            <p:ph type="title"/>
+          </p:nvPr>
+        </p:nvSpPr>
+        <p:spPr>
+          <a:xfrm>
+            <a:off x="453007" y="171974"/>
+            <a:ext cx="8493900" cy="885000"/>
+          </a:xfrm>
+          <a:prstGeom prst="rect">
+            <a:avLst/>
+          </a:prstGeom>
+        </p:spPr>
+        <p:txBody>
+          <a:bodyPr spcFirstLastPara="1" wrap="square" lIns="91425" tIns="45700" rIns="91425" bIns="45700" anchor="ctr" anchorCtr="0">
+            <a:normAutofit/>
+          </a:bodyPr>
+          <a:lstStyle/>
+          <a:p>
+            <a:pPr marL="0" lvl="0" indent="0" algn="l" rtl="0">
+              <a:spcBef>
+                <a:spcPts val="0"/>
+              </a:spcBef>
+              <a:spcAft>
+                <a:spcPts val="0"/>
+              </a:spcAft>
+              <a:buNone/>
+            </a:pPr>
+            <a:r>
+              <a:rPr lang="en-US" b="0"/>
+              <a:t>Data Visualization</a:t>
+            </a:r>
+            <a:endParaRPr b="0"/>
+          </a:p>
+        </p:txBody>
+      </p:sp>
+      <p:sp>
+        <p:nvSpPr>
+          <p:cNvPr id="111" name="Google Shape;111;g10a5157cc27_0_0"/>
+          <p:cNvSpPr txBox="1">
+            <a:spLocks noGrp="1"/>
+          </p:cNvSpPr>
+          <p:nvPr>
+            <p:ph type="body" idx="1"/>
+          </p:nvPr>
+        </p:nvSpPr>
+        <p:spPr>
+          <a:xfrm>
+            <a:off x="453006" y="1157681"/>
+            <a:ext cx="8493900" cy="5234700"/>
+          </a:xfrm>
+          <a:prstGeom prst="rect">
+            <a:avLst/>
+          </a:prstGeom>
+        </p:spPr>
+        <p:txBody>
+          <a:bodyPr spcFirstLastPara="1" wrap="square" lIns="91425" tIns="45700" rIns="91425" bIns="45700" anchor="t" anchorCtr="0">
+            <a:normAutofit/>
+          </a:bodyPr>
+          <a:lstStyle/>
+          <a:p>
+            <a:pPr marL="0" lvl="0" indent="0" algn="l" rtl="0">
+              <a:lnSpc>
+                <a:spcPct val="113000"/>
+              </a:lnSpc>
+              <a:spcBef>
+                <a:spcPts val="0"/>
+              </a:spcBef>
+              <a:spcAft>
+                <a:spcPts val="0"/>
+              </a:spcAft>
+              <a:buClr>
+                <a:schemeClr val="dk1"/>
+              </a:buClr>
+              <a:buSzPts val="1100"/>
+              <a:buFont typeface="Arial"/>
+              <a:buNone/>
+            </a:pPr>
+            <a:r>
+              <a:rPr lang="en-US" sz="2000"/>
+              <a:t>Here are a set of simple steps for selecting appropriate data visualization:</a:t>
+            </a:r>
+            <a:endParaRPr sz="2000"/>
+          </a:p>
+          <a:p>
+            <a:pPr marL="0" lvl="0" indent="0" algn="l" rtl="0">
+              <a:lnSpc>
+                <a:spcPct val="113000"/>
+              </a:lnSpc>
+              <a:spcBef>
+                <a:spcPts val="1200"/>
+              </a:spcBef>
+              <a:spcAft>
+                <a:spcPts val="0"/>
+              </a:spcAft>
+              <a:buClr>
+                <a:schemeClr val="dk1"/>
+              </a:buClr>
+              <a:buSzPts val="1100"/>
+              <a:buFont typeface="Arial"/>
+              <a:buNone/>
+            </a:pPr>
+            <a:r>
+              <a:rPr lang="en-US" sz="2000" b="1"/>
+              <a:t>Step 1:</a:t>
+            </a:r>
+            <a:r>
+              <a:rPr lang="en-US" sz="2000"/>
+              <a:t> Identify your audience.</a:t>
+            </a:r>
+            <a:endParaRPr sz="2000"/>
+          </a:p>
+          <a:p>
+            <a:pPr marL="0" lvl="0" indent="0" algn="l" rtl="0">
+              <a:lnSpc>
+                <a:spcPct val="113000"/>
+              </a:lnSpc>
+              <a:spcBef>
+                <a:spcPts val="1200"/>
+              </a:spcBef>
+              <a:spcAft>
+                <a:spcPts val="0"/>
+              </a:spcAft>
+              <a:buClr>
+                <a:schemeClr val="dk1"/>
+              </a:buClr>
+              <a:buSzPts val="1100"/>
+              <a:buFont typeface="Arial"/>
+              <a:buNone/>
+            </a:pPr>
+            <a:r>
+              <a:rPr lang="en-US" sz="2000" b="1"/>
+              <a:t>Step 2: </a:t>
+            </a:r>
+            <a:r>
+              <a:rPr lang="en-US" sz="2000"/>
+              <a:t>Identify questions to be answered by your visualization.</a:t>
+            </a:r>
+            <a:endParaRPr sz="2000"/>
+          </a:p>
+          <a:p>
+            <a:pPr marL="0" lvl="0" indent="0" algn="l" rtl="0">
+              <a:lnSpc>
+                <a:spcPct val="113000"/>
+              </a:lnSpc>
+              <a:spcBef>
+                <a:spcPts val="1200"/>
+              </a:spcBef>
+              <a:spcAft>
+                <a:spcPts val="0"/>
+              </a:spcAft>
+              <a:buClr>
+                <a:schemeClr val="dk1"/>
+              </a:buClr>
+              <a:buSzPts val="1100"/>
+              <a:buFont typeface="Arial"/>
+              <a:buNone/>
+            </a:pPr>
+            <a:r>
+              <a:rPr lang="en-US" sz="2000" b="1"/>
+              <a:t>Step 3</a:t>
+            </a:r>
+            <a:r>
+              <a:rPr lang="en-US" sz="2000"/>
+              <a:t>: Think of possible constraints or challenges (e.g., budget limitations, the speed at which the study can be completed, or the dependability of your data) and ask the following questions:</a:t>
+            </a:r>
+            <a:endParaRPr sz="2000"/>
+          </a:p>
+          <a:p>
+            <a:pPr marL="457200" lvl="0" indent="-355600" algn="l" rtl="0">
+              <a:lnSpc>
+                <a:spcPct val="113000"/>
+              </a:lnSpc>
+              <a:spcBef>
+                <a:spcPts val="1200"/>
+              </a:spcBef>
+              <a:spcAft>
+                <a:spcPts val="0"/>
+              </a:spcAft>
+              <a:buSzPts val="2000"/>
+              <a:buChar char="●"/>
+            </a:pPr>
+            <a:r>
+              <a:rPr lang="en-US" sz="2000"/>
+              <a:t>Is my data reliable?</a:t>
+            </a:r>
+            <a:endParaRPr sz="2000"/>
+          </a:p>
+          <a:p>
+            <a:pPr marL="457200" lvl="0" indent="-355600" algn="l" rtl="0">
+              <a:lnSpc>
+                <a:spcPct val="113000"/>
+              </a:lnSpc>
+              <a:spcBef>
+                <a:spcPts val="0"/>
+              </a:spcBef>
+              <a:spcAft>
+                <a:spcPts val="0"/>
+              </a:spcAft>
+              <a:buSzPts val="2000"/>
+              <a:buChar char="●"/>
+            </a:pPr>
+            <a:r>
+              <a:rPr lang="en-US" sz="2000"/>
+              <a:t>Is the value of the analysis greater than the cost?</a:t>
+            </a:r>
+            <a:endParaRPr sz="2000"/>
+          </a:p>
+          <a:p>
+            <a:pPr marL="457200" lvl="0" indent="-355600" algn="l" rtl="0">
+              <a:lnSpc>
+                <a:spcPct val="113000"/>
+              </a:lnSpc>
+              <a:spcBef>
+                <a:spcPts val="0"/>
+              </a:spcBef>
+              <a:spcAft>
+                <a:spcPts val="0"/>
+              </a:spcAft>
+              <a:buSzPts val="2000"/>
+              <a:buChar char="●"/>
+            </a:pPr>
+            <a:r>
+              <a:rPr lang="en-US" sz="2000"/>
+              <a:t>How will I store my data?</a:t>
+            </a:r>
+            <a:endParaRPr sz="2000"/>
+          </a:p>
+          <a:p>
+            <a:pPr marL="457200" lvl="0" indent="-355600" algn="l" rtl="0">
+              <a:lnSpc>
+                <a:spcPct val="113000"/>
+              </a:lnSpc>
+              <a:spcBef>
+                <a:spcPts val="0"/>
+              </a:spcBef>
+              <a:spcAft>
+                <a:spcPts val="0"/>
+              </a:spcAft>
+              <a:buSzPts val="2000"/>
+              <a:buChar char="●"/>
+            </a:pPr>
+            <a:r>
+              <a:rPr lang="en-US" sz="2000"/>
+              <a:t>Is the data owned or controlled by someone else?</a:t>
+            </a:r>
+            <a:endParaRPr sz="2000"/>
+          </a:p>
+          <a:p>
+            <a:pPr marL="0" lvl="0" indent="0" algn="l" rtl="0">
+              <a:lnSpc>
+                <a:spcPct val="113000"/>
+              </a:lnSpc>
+              <a:spcBef>
+                <a:spcPts val="1200"/>
+              </a:spcBef>
+              <a:spcAft>
+                <a:spcPts val="0"/>
+              </a:spcAft>
+              <a:buClr>
+                <a:schemeClr val="dk1"/>
+              </a:buClr>
+              <a:buSzPts val="1100"/>
+              <a:buFont typeface="Arial"/>
+              <a:buNone/>
+            </a:pPr>
+            <a:r>
+              <a:rPr lang="en-US" sz="2000" b="1"/>
+              <a:t>Step 4: </a:t>
+            </a:r>
+            <a:r>
+              <a:rPr lang="en-US" sz="2000"/>
+              <a:t>Select the appropriate visualization.</a:t>
+            </a:r>
+            <a:endParaRPr sz="2000">
+              <a:highlight>
+                <a:srgbClr val="FFFF00"/>
+              </a:highlight>
+            </a:endParaRPr>
+          </a:p>
+          <a:p>
+            <a:pPr marL="0" lvl="0" indent="0" algn="l" rtl="0">
+              <a:spcBef>
+                <a:spcPts val="1200"/>
+              </a:spcBef>
+              <a:spcAft>
+                <a:spcPts val="0"/>
+              </a:spcAft>
+              <a:buNone/>
+            </a:pPr>
+            <a:endParaRPr/>
+          </a:p>
+        </p:txBody>
+      </p:sp>
+    </p:spTree>
+  </p:cSld>
+  <p:clrMapOvr>
+    <a:masterClrMapping/>
+  </p:clrMapOvr>
+</p:sld>
+</file>
+
+<file path=ppt/slides/slide13.xml><?xml version="1.0" encoding="utf-8"?>
+<p:sld xmlns:a="http://schemas.openxmlformats.org/drawingml/2006/main" xmlns:r="http://schemas.openxmlformats.org/officeDocument/2006/relationships" xmlns:p="http://schemas.openxmlformats.org/presentationml/2006/main">
+  <p:cSld>
+    <p:spTree>
+      <p:nvGrpSpPr>
         <p:cNvPr id="1" name="Shape 116"/>
         <p:cNvGrpSpPr/>
         <p:nvPr/>
@@ -26291,7 +27267,7 @@
 </p:sld>
 </file>
 
-<file path=ppt/slides/slide11.xml><?xml version="1.0" encoding="utf-8"?>
+<file path=ppt/slides/slide14.xml><?xml version="1.0" encoding="utf-8"?>
 <p:sld xmlns:a="http://schemas.openxmlformats.org/drawingml/2006/main" xmlns:r="http://schemas.openxmlformats.org/officeDocument/2006/relationships" xmlns:p="http://schemas.openxmlformats.org/presentationml/2006/main">
   <p:cSld>
     <p:spTree>
@@ -26481,7 +27457,7 @@
 </p:sld>
 </file>
 
-<file path=ppt/slides/slide12.xml><?xml version="1.0" encoding="utf-8"?>
+<file path=ppt/slides/slide15.xml><?xml version="1.0" encoding="utf-8"?>
 <p:sld xmlns:a="http://schemas.openxmlformats.org/drawingml/2006/main" xmlns:r="http://schemas.openxmlformats.org/officeDocument/2006/relationships" xmlns:p="http://schemas.openxmlformats.org/presentationml/2006/main">
   <p:cSld>
     <p:spTree>
@@ -26629,7 +27605,7 @@
 </p:sld>
 </file>
 
-<file path=ppt/slides/slide13.xml><?xml version="1.0" encoding="utf-8"?>
+<file path=ppt/slides/slide16.xml><?xml version="1.0" encoding="utf-8"?>
 <p:sld xmlns:a="http://schemas.openxmlformats.org/drawingml/2006/main" xmlns:r="http://schemas.openxmlformats.org/officeDocument/2006/relationships" xmlns:p="http://schemas.openxmlformats.org/presentationml/2006/main">
   <p:cSld>
     <p:spTree>
@@ -26789,7 +27765,7 @@
 </p:sld>
 </file>
 
-<file path=ppt/slides/slide14.xml><?xml version="1.0" encoding="utf-8"?>
+<file path=ppt/slides/slide17.xml><?xml version="1.0" encoding="utf-8"?>
 <p:sld xmlns:a="http://schemas.openxmlformats.org/drawingml/2006/main" xmlns:r="http://schemas.openxmlformats.org/officeDocument/2006/relationships" xmlns:p="http://schemas.openxmlformats.org/presentationml/2006/main">
   <p:cSld>
     <p:spTree>
@@ -26964,7 +27940,7 @@
 </p:sld>
 </file>
 
-<file path=ppt/slides/slide15.xml><?xml version="1.0" encoding="utf-8"?>
+<file path=ppt/slides/slide18.xml><?xml version="1.0" encoding="utf-8"?>
 <p:sld xmlns:a="http://schemas.openxmlformats.org/drawingml/2006/main" xmlns:r="http://schemas.openxmlformats.org/officeDocument/2006/relationships" xmlns:p="http://schemas.openxmlformats.org/presentationml/2006/main">
   <p:cSld>
     <p:spTree>
@@ -27110,7 +28086,7 @@
 </p:sld>
 </file>
 
-<file path=ppt/slides/slide16.xml><?xml version="1.0" encoding="utf-8"?>
+<file path=ppt/slides/slide19.xml><?xml version="1.0" encoding="utf-8"?>
 <p:sld xmlns:a="http://schemas.openxmlformats.org/drawingml/2006/main" xmlns:r="http://schemas.openxmlformats.org/officeDocument/2006/relationships" xmlns:p="http://schemas.openxmlformats.org/presentationml/2006/main">
   <p:cSld>
     <p:spTree>
@@ -27218,7 +28194,196 @@
 </p:sld>
 </file>
 
-<file path=ppt/slides/slide17.xml><?xml version="1.0" encoding="utf-8"?>
+<file path=ppt/slides/slide2.xml><?xml version="1.0" encoding="utf-8"?>
+<p:sld xmlns:a="http://schemas.openxmlformats.org/drawingml/2006/main" xmlns:r="http://schemas.openxmlformats.org/officeDocument/2006/relationships" xmlns:p="http://schemas.openxmlformats.org/presentationml/2006/main">
+  <p:cSld>
+    <p:spTree>
+      <p:nvGrpSpPr>
+        <p:cNvPr id="1" name="Shape 63"/>
+        <p:cNvGrpSpPr/>
+        <p:nvPr/>
+      </p:nvGrpSpPr>
+      <p:grpSpPr>
+        <a:xfrm>
+          <a:off x="0" y="0"/>
+          <a:ext cx="0" cy="0"/>
+          <a:chOff x="0" y="0"/>
+          <a:chExt cx="0" cy="0"/>
+        </a:xfrm>
+      </p:grpSpPr>
+      <p:sp>
+        <p:nvSpPr>
+          <p:cNvPr id="64" name="Google Shape;64;p2"/>
+          <p:cNvSpPr txBox="1">
+            <a:spLocks noGrp="1"/>
+          </p:cNvSpPr>
+          <p:nvPr>
+            <p:ph type="title"/>
+          </p:nvPr>
+        </p:nvSpPr>
+        <p:spPr>
+          <a:xfrm>
+            <a:off x="453000" y="171975"/>
+            <a:ext cx="8227500" cy="885000"/>
+          </a:xfrm>
+          <a:prstGeom prst="rect">
+            <a:avLst/>
+          </a:prstGeom>
+          <a:noFill/>
+          <a:ln>
+            <a:noFill/>
+          </a:ln>
+        </p:spPr>
+        <p:txBody>
+          <a:bodyPr spcFirstLastPara="1" wrap="square" lIns="91425" tIns="45700" rIns="91425" bIns="45700" anchor="ctr" anchorCtr="0">
+            <a:normAutofit/>
+          </a:bodyPr>
+          <a:lstStyle/>
+          <a:p>
+            <a:pPr marL="0" lvl="0" indent="0" algn="l" rtl="0">
+              <a:lnSpc>
+                <a:spcPct val="90000"/>
+              </a:lnSpc>
+              <a:spcBef>
+                <a:spcPts val="0"/>
+              </a:spcBef>
+              <a:spcAft>
+                <a:spcPts val="0"/>
+              </a:spcAft>
+              <a:buClr>
+                <a:srgbClr val="0070C0"/>
+              </a:buClr>
+              <a:buSzPts val="4400"/>
+              <a:buFont typeface="Calibri"/>
+              <a:buNone/>
+            </a:pPr>
+            <a:r>
+              <a:rPr lang="en-US" b="0"/>
+              <a:t>Learning Goals</a:t>
+            </a:r>
+            <a:endParaRPr b="0"/>
+          </a:p>
+        </p:txBody>
+      </p:sp>
+      <p:sp>
+        <p:nvSpPr>
+          <p:cNvPr id="65" name="Google Shape;65;p2"/>
+          <p:cNvSpPr txBox="1">
+            <a:spLocks noGrp="1"/>
+          </p:cNvSpPr>
+          <p:nvPr>
+            <p:ph type="body" idx="1"/>
+          </p:nvPr>
+        </p:nvSpPr>
+        <p:spPr>
+          <a:xfrm>
+            <a:off x="453000" y="1157675"/>
+            <a:ext cx="8227500" cy="5289000"/>
+          </a:xfrm>
+          <a:prstGeom prst="rect">
+            <a:avLst/>
+          </a:prstGeom>
+          <a:noFill/>
+          <a:ln>
+            <a:noFill/>
+          </a:ln>
+        </p:spPr>
+        <p:txBody>
+          <a:bodyPr spcFirstLastPara="1" wrap="square" lIns="91425" tIns="45700" rIns="91425" bIns="45700" anchor="t" anchorCtr="0">
+            <a:normAutofit/>
+          </a:bodyPr>
+          <a:lstStyle/>
+          <a:p>
+            <a:pPr marL="457200" lvl="0" indent="-355600" algn="l" rtl="0">
+              <a:lnSpc>
+                <a:spcPct val="100000"/>
+              </a:lnSpc>
+              <a:spcBef>
+                <a:spcPts val="0"/>
+              </a:spcBef>
+              <a:spcAft>
+                <a:spcPts val="0"/>
+              </a:spcAft>
+              <a:buSzPts val="2000"/>
+              <a:buChar char="●"/>
+            </a:pPr>
+            <a:r>
+              <a:rPr lang="en-US" sz="2000" dirty="0"/>
+              <a:t>Assess different data visualization techniques and discuss their advantages and limitations. </a:t>
+            </a:r>
+            <a:endParaRPr sz="2000" dirty="0"/>
+          </a:p>
+          <a:p>
+            <a:pPr marL="457200" lvl="0" indent="-355600" algn="l" rtl="0">
+              <a:lnSpc>
+                <a:spcPct val="100000"/>
+              </a:lnSpc>
+              <a:spcBef>
+                <a:spcPts val="0"/>
+              </a:spcBef>
+              <a:spcAft>
+                <a:spcPts val="0"/>
+              </a:spcAft>
+              <a:buSzPts val="2000"/>
+              <a:buChar char="●"/>
+            </a:pPr>
+            <a:r>
+              <a:rPr lang="en-US" sz="2000" dirty="0"/>
+              <a:t>Decide on a method to validate, prepare, and communicate insights to key stakeholders.</a:t>
+            </a:r>
+            <a:endParaRPr sz="2000" dirty="0"/>
+          </a:p>
+          <a:p>
+            <a:pPr marL="457200" lvl="0" indent="-355600" algn="l" rtl="0">
+              <a:lnSpc>
+                <a:spcPct val="100000"/>
+              </a:lnSpc>
+              <a:spcBef>
+                <a:spcPts val="0"/>
+              </a:spcBef>
+              <a:spcAft>
+                <a:spcPts val="0"/>
+              </a:spcAft>
+              <a:buSzPts val="2000"/>
+              <a:buChar char="●"/>
+            </a:pPr>
+            <a:r>
+              <a:rPr lang="en-US" sz="2000" dirty="0"/>
+              <a:t>Organize data using a pivot table in Excel.</a:t>
+            </a:r>
+            <a:endParaRPr sz="2000" dirty="0"/>
+          </a:p>
+          <a:p>
+            <a:pPr marL="457200" lvl="0" indent="-355600" algn="l" rtl="0">
+              <a:lnSpc>
+                <a:spcPct val="100000"/>
+              </a:lnSpc>
+              <a:spcBef>
+                <a:spcPts val="0"/>
+              </a:spcBef>
+              <a:spcAft>
+                <a:spcPts val="0"/>
+              </a:spcAft>
+              <a:buSzPts val="2000"/>
+              <a:buChar char="●"/>
+            </a:pPr>
+            <a:r>
+              <a:rPr lang="en-US" sz="2000" dirty="0"/>
+              <a:t>Describe the process of data manipulation and techniques using Excel.</a:t>
+            </a:r>
+            <a:endParaRPr sz="2000" dirty="0"/>
+          </a:p>
+        </p:txBody>
+      </p:sp>
+    </p:spTree>
+  </p:cSld>
+  <p:clrMapOvr>
+    <a:masterClrMapping/>
+  </p:clrMapOvr>
+</p:sld>
+</file>
+
+<file path=ppt/slides/slide20.xml><?xml version="1.0" encoding="utf-8"?>
 <p:sld xmlns:a="http://schemas.openxmlformats.org/drawingml/2006/main" xmlns:r="http://schemas.openxmlformats.org/officeDocument/2006/relationships" xmlns:p="http://schemas.openxmlformats.org/presentationml/2006/main">
   <p:cSld>
     <p:spTree>
@@ -27317,7 +28482,7 @@
 </p:sld>
 </file>
 
-<file path=ppt/slides/slide18.xml><?xml version="1.0" encoding="utf-8"?>
+<file path=ppt/slides/slide21.xml><?xml version="1.0" encoding="utf-8"?>
 <p:sld xmlns:a="http://schemas.openxmlformats.org/drawingml/2006/main" xmlns:r="http://schemas.openxmlformats.org/officeDocument/2006/relationships" xmlns:p="http://schemas.openxmlformats.org/presentationml/2006/main">
   <p:cSld>
     <p:spTree>
@@ -27454,7 +28619,7 @@
 </p:sld>
 </file>
 
-<file path=ppt/slides/slide19.xml><?xml version="1.0" encoding="utf-8"?>
+<file path=ppt/slides/slide22.xml><?xml version="1.0" encoding="utf-8"?>
 <p:sld xmlns:a="http://schemas.openxmlformats.org/drawingml/2006/main" xmlns:r="http://schemas.openxmlformats.org/officeDocument/2006/relationships" xmlns:p="http://schemas.openxmlformats.org/presentationml/2006/main">
   <p:cSld>
     <p:spTree>
@@ -27617,196 +28782,7 @@
 </p:sld>
 </file>
 
-<file path=ppt/slides/slide2.xml><?xml version="1.0" encoding="utf-8"?>
-<p:sld xmlns:a="http://schemas.openxmlformats.org/drawingml/2006/main" xmlns:r="http://schemas.openxmlformats.org/officeDocument/2006/relationships" xmlns:p="http://schemas.openxmlformats.org/presentationml/2006/main">
-  <p:cSld>
-    <p:spTree>
-      <p:nvGrpSpPr>
-        <p:cNvPr id="1" name="Shape 63"/>
-        <p:cNvGrpSpPr/>
-        <p:nvPr/>
-      </p:nvGrpSpPr>
-      <p:grpSpPr>
-        <a:xfrm>
-          <a:off x="0" y="0"/>
-          <a:ext cx="0" cy="0"/>
-          <a:chOff x="0" y="0"/>
-          <a:chExt cx="0" cy="0"/>
-        </a:xfrm>
-      </p:grpSpPr>
-      <p:sp>
-        <p:nvSpPr>
-          <p:cNvPr id="64" name="Google Shape;64;p2"/>
-          <p:cNvSpPr txBox="1">
-            <a:spLocks noGrp="1"/>
-          </p:cNvSpPr>
-          <p:nvPr>
-            <p:ph type="title"/>
-          </p:nvPr>
-        </p:nvSpPr>
-        <p:spPr>
-          <a:xfrm>
-            <a:off x="453000" y="171975"/>
-            <a:ext cx="8227500" cy="885000"/>
-          </a:xfrm>
-          <a:prstGeom prst="rect">
-            <a:avLst/>
-          </a:prstGeom>
-          <a:noFill/>
-          <a:ln>
-            <a:noFill/>
-          </a:ln>
-        </p:spPr>
-        <p:txBody>
-          <a:bodyPr spcFirstLastPara="1" wrap="square" lIns="91425" tIns="45700" rIns="91425" bIns="45700" anchor="ctr" anchorCtr="0">
-            <a:normAutofit/>
-          </a:bodyPr>
-          <a:lstStyle/>
-          <a:p>
-            <a:pPr marL="0" lvl="0" indent="0" algn="l" rtl="0">
-              <a:lnSpc>
-                <a:spcPct val="90000"/>
-              </a:lnSpc>
-              <a:spcBef>
-                <a:spcPts val="0"/>
-              </a:spcBef>
-              <a:spcAft>
-                <a:spcPts val="0"/>
-              </a:spcAft>
-              <a:buClr>
-                <a:srgbClr val="0070C0"/>
-              </a:buClr>
-              <a:buSzPts val="4400"/>
-              <a:buFont typeface="Calibri"/>
-              <a:buNone/>
-            </a:pPr>
-            <a:r>
-              <a:rPr lang="en-US" b="0"/>
-              <a:t>Learning Goals</a:t>
-            </a:r>
-            <a:endParaRPr b="0"/>
-          </a:p>
-        </p:txBody>
-      </p:sp>
-      <p:sp>
-        <p:nvSpPr>
-          <p:cNvPr id="65" name="Google Shape;65;p2"/>
-          <p:cNvSpPr txBox="1">
-            <a:spLocks noGrp="1"/>
-          </p:cNvSpPr>
-          <p:nvPr>
-            <p:ph type="body" idx="1"/>
-          </p:nvPr>
-        </p:nvSpPr>
-        <p:spPr>
-          <a:xfrm>
-            <a:off x="453000" y="1157675"/>
-            <a:ext cx="8227500" cy="5289000"/>
-          </a:xfrm>
-          <a:prstGeom prst="rect">
-            <a:avLst/>
-          </a:prstGeom>
-          <a:noFill/>
-          <a:ln>
-            <a:noFill/>
-          </a:ln>
-        </p:spPr>
-        <p:txBody>
-          <a:bodyPr spcFirstLastPara="1" wrap="square" lIns="91425" tIns="45700" rIns="91425" bIns="45700" anchor="t" anchorCtr="0">
-            <a:normAutofit/>
-          </a:bodyPr>
-          <a:lstStyle/>
-          <a:p>
-            <a:pPr marL="457200" lvl="0" indent="-355600" algn="l" rtl="0">
-              <a:lnSpc>
-                <a:spcPct val="100000"/>
-              </a:lnSpc>
-              <a:spcBef>
-                <a:spcPts val="0"/>
-              </a:spcBef>
-              <a:spcAft>
-                <a:spcPts val="0"/>
-              </a:spcAft>
-              <a:buSzPts val="2000"/>
-              <a:buChar char="●"/>
-            </a:pPr>
-            <a:r>
-              <a:rPr lang="en-US" sz="2000" dirty="0"/>
-              <a:t>Assess different data visualization techniques and discuss their advantages and limitations. </a:t>
-            </a:r>
-            <a:endParaRPr sz="2000" dirty="0"/>
-          </a:p>
-          <a:p>
-            <a:pPr marL="457200" lvl="0" indent="-355600" algn="l" rtl="0">
-              <a:lnSpc>
-                <a:spcPct val="100000"/>
-              </a:lnSpc>
-              <a:spcBef>
-                <a:spcPts val="0"/>
-              </a:spcBef>
-              <a:spcAft>
-                <a:spcPts val="0"/>
-              </a:spcAft>
-              <a:buSzPts val="2000"/>
-              <a:buChar char="●"/>
-            </a:pPr>
-            <a:r>
-              <a:rPr lang="en-US" sz="2000" dirty="0"/>
-              <a:t>Decide on a method to validate, prepare, and communicate insights to key stakeholders.</a:t>
-            </a:r>
-            <a:endParaRPr sz="2000" dirty="0"/>
-          </a:p>
-          <a:p>
-            <a:pPr marL="457200" lvl="0" indent="-355600" algn="l" rtl="0">
-              <a:lnSpc>
-                <a:spcPct val="100000"/>
-              </a:lnSpc>
-              <a:spcBef>
-                <a:spcPts val="0"/>
-              </a:spcBef>
-              <a:spcAft>
-                <a:spcPts val="0"/>
-              </a:spcAft>
-              <a:buSzPts val="2000"/>
-              <a:buChar char="●"/>
-            </a:pPr>
-            <a:r>
-              <a:rPr lang="en-US" sz="2000" dirty="0"/>
-              <a:t>Organize data using a pivot table in Excel.</a:t>
-            </a:r>
-            <a:endParaRPr sz="2000" dirty="0"/>
-          </a:p>
-          <a:p>
-            <a:pPr marL="457200" lvl="0" indent="-355600" algn="l" rtl="0">
-              <a:lnSpc>
-                <a:spcPct val="100000"/>
-              </a:lnSpc>
-              <a:spcBef>
-                <a:spcPts val="0"/>
-              </a:spcBef>
-              <a:spcAft>
-                <a:spcPts val="0"/>
-              </a:spcAft>
-              <a:buSzPts val="2000"/>
-              <a:buChar char="●"/>
-            </a:pPr>
-            <a:r>
-              <a:rPr lang="en-US" sz="2000" dirty="0"/>
-              <a:t>Describe the process of data manipulation and techniques using Excel.</a:t>
-            </a:r>
-            <a:endParaRPr sz="2000" dirty="0"/>
-          </a:p>
-        </p:txBody>
-      </p:sp>
-    </p:spTree>
-  </p:cSld>
-  <p:clrMapOvr>
-    <a:masterClrMapping/>
-  </p:clrMapOvr>
-</p:sld>
-</file>
-
-<file path=ppt/slides/slide20.xml><?xml version="1.0" encoding="utf-8"?>
+<file path=ppt/slides/slide23.xml><?xml version="1.0" encoding="utf-8"?>
 <p:sld xmlns:a="http://schemas.openxmlformats.org/drawingml/2006/main" xmlns:r="http://schemas.openxmlformats.org/officeDocument/2006/relationships" xmlns:p="http://schemas.openxmlformats.org/presentationml/2006/main">
   <p:cSld>
     <p:spTree>
@@ -27914,7 +28890,127 @@
 </p:sld>
 </file>
 
-<file path=ppt/slides/slide21.xml><?xml version="1.0" encoding="utf-8"?>
+<file path=ppt/slides/slide24.xml><?xml version="1.0" encoding="utf-8"?>
+<p:sld xmlns:a="http://schemas.openxmlformats.org/drawingml/2006/main" xmlns:r="http://schemas.openxmlformats.org/officeDocument/2006/relationships" xmlns:p="http://schemas.openxmlformats.org/presentationml/2006/main">
+  <p:cSld>
+    <p:spTree>
+      <p:nvGrpSpPr>
+        <p:cNvPr id="1" name=""/>
+        <p:cNvGrpSpPr/>
+        <p:nvPr/>
+      </p:nvGrpSpPr>
+      <p:grpSpPr>
+        <a:xfrm>
+          <a:off x="0" y="0"/>
+          <a:ext cx="0" cy="0"/>
+          <a:chOff x="0" y="0"/>
+          <a:chExt cx="0" cy="0"/>
+        </a:xfrm>
+      </p:grpSpPr>
+      <p:sp>
+        <p:nvSpPr>
+          <p:cNvPr id="2" name="Title 1">
+            <a:extLst>
+              <a:ext uri="{FF2B5EF4-FFF2-40B4-BE49-F238E27FC236}">
+                <a16:creationId xmlns:a16="http://schemas.microsoft.com/office/drawing/2014/main" id="{68377356-480F-4017-8219-5B4BF0081763}"/>
+              </a:ext>
+            </a:extLst>
+          </p:cNvPr>
+          <p:cNvSpPr>
+            <a:spLocks noGrp="1"/>
+          </p:cNvSpPr>
+          <p:nvPr>
+            <p:ph type="title"/>
+          </p:nvPr>
+        </p:nvSpPr>
+        <p:spPr/>
+        <p:txBody>
+          <a:bodyPr/>
+          <a:lstStyle/>
+          <a:p>
+            <a:r>
+              <a:rPr lang="en-US" dirty="0"/>
+              <a:t>Final Project Check in</a:t>
+            </a:r>
+          </a:p>
+        </p:txBody>
+      </p:sp>
+      <p:sp>
+        <p:nvSpPr>
+          <p:cNvPr id="3" name="Text Placeholder 2">
+            <a:extLst>
+              <a:ext uri="{FF2B5EF4-FFF2-40B4-BE49-F238E27FC236}">
+                <a16:creationId xmlns:a16="http://schemas.microsoft.com/office/drawing/2014/main" id="{146B8F0D-5E16-4158-BAE4-B6B34DF8D133}"/>
+              </a:ext>
+            </a:extLst>
+          </p:cNvPr>
+          <p:cNvSpPr>
+            <a:spLocks noGrp="1"/>
+          </p:cNvSpPr>
+          <p:nvPr>
+            <p:ph type="body" idx="1"/>
+          </p:nvPr>
+        </p:nvSpPr>
+        <p:spPr/>
+        <p:txBody>
+          <a:bodyPr/>
+          <a:lstStyle/>
+          <a:p>
+            <a:pPr marL="514350" indent="-285750">
+              <a:buFont typeface="Arial" panose="020B0604020202020204" pitchFamily="34" charset="0"/>
+              <a:buChar char="•"/>
+            </a:pPr>
+            <a:r>
+              <a:rPr lang="en-US" dirty="0"/>
+              <a:t>Grouping</a:t>
+            </a:r>
+          </a:p>
+          <a:p>
+            <a:pPr marL="514350" indent="-285750">
+              <a:buFont typeface="Arial" panose="020B0604020202020204" pitchFamily="34" charset="0"/>
+              <a:buChar char="•"/>
+            </a:pPr>
+            <a:r>
+              <a:rPr lang="en-US" dirty="0"/>
+              <a:t>Topic selection </a:t>
+            </a:r>
+          </a:p>
+          <a:p>
+            <a:pPr marL="514350" indent="-285750">
+              <a:buFont typeface="Arial" panose="020B0604020202020204" pitchFamily="34" charset="0"/>
+              <a:buChar char="•"/>
+            </a:pPr>
+            <a:r>
+              <a:rPr lang="en-US" dirty="0"/>
+              <a:t>Progress OR questions?</a:t>
+            </a:r>
+          </a:p>
+          <a:p>
+            <a:pPr marL="514350" indent="-285750">
+              <a:buFont typeface="Arial" panose="020B0604020202020204" pitchFamily="34" charset="0"/>
+              <a:buChar char="•"/>
+            </a:pPr>
+            <a:r>
+              <a:rPr lang="en-US" dirty="0"/>
+              <a:t>Schedule a meeting with each groups</a:t>
+            </a:r>
+          </a:p>
+        </p:txBody>
+      </p:sp>
+    </p:spTree>
+    <p:extLst>
+      <p:ext uri="{BB962C8B-B14F-4D97-AF65-F5344CB8AC3E}">
+        <p14:creationId xmlns:p14="http://schemas.microsoft.com/office/powerpoint/2010/main" val="855432890"/>
+      </p:ext>
+    </p:extLst>
+  </p:cSld>
+  <p:clrMapOvr>
+    <a:masterClrMapping/>
+  </p:clrMapOvr>
+</p:sld>
+</file>
+
+<file path=ppt/slides/slide25.xml><?xml version="1.0" encoding="utf-8"?>
 <p:sld xmlns:a="http://schemas.openxmlformats.org/drawingml/2006/main" xmlns:r="http://schemas.openxmlformats.org/officeDocument/2006/relationships" xmlns:p="http://schemas.openxmlformats.org/presentationml/2006/main">
   <p:cSld>
     <p:spTree>
@@ -28014,6 +29110,44 @@
           </a:bodyPr>
           <a:lstStyle/>
           <a:p>
+            <a:r>
+              <a:rPr lang="en-US" sz="2000" b="1" dirty="0"/>
+              <a:t>Using predictive analytics for the oil and gas digital </a:t>
+            </a:r>
+          </a:p>
+          <a:p>
+            <a:r>
+              <a:rPr lang="en-US" sz="2000" dirty="0"/>
+              <a:t>One of the biggest data-driven use cases is for predictive maintenance, which utilizes time-series data from hundreds of sensors on equipment at each rig site, as well as maintenance records and operational information from various databases to generate rig data analytic lifecycles, adding predictive capabilities to a digital system to dramatically increase its insights to the oil spills.</a:t>
+            </a:r>
+          </a:p>
+          <a:p>
+            <a:pPr marL="101600" marR="0" lvl="0" indent="0" algn="l" rtl="0">
+              <a:lnSpc>
+                <a:spcPct val="115000"/>
+              </a:lnSpc>
+              <a:spcBef>
+                <a:spcPts val="1000"/>
+              </a:spcBef>
+              <a:spcAft>
+                <a:spcPts val="0"/>
+              </a:spcAft>
+              <a:buClr>
+                <a:srgbClr val="000000"/>
+              </a:buClr>
+              <a:buSzPts val="2000"/>
+            </a:pPr>
+            <a:endParaRPr lang="en-US" sz="2000" b="0" i="0" u="none" strike="noStrike" cap="none" dirty="0">
+              <a:solidFill>
+                <a:srgbClr val="000000"/>
+              </a:solidFill>
+              <a:latin typeface="Open Sans"/>
+              <a:ea typeface="Open Sans"/>
+              <a:cs typeface="Open Sans"/>
+              <a:sym typeface="Open Sans"/>
+            </a:endParaRPr>
+          </a:p>
+          <a:p>
             <a:pPr marL="457200" marR="0" lvl="0" indent="-355600" algn="l" rtl="0">
               <a:lnSpc>
                 <a:spcPct val="115000"/>
@@ -28072,29 +29206,8 @@
                 <a:cs typeface="Open Sans"/>
                 <a:sym typeface="Open Sans"/>
               </a:rPr>
-              <a:t>How to solve the “Oil Spill</a:t>
+              <a:t>How to solve the “Oil Spill” crises</a:t>
             </a:r>
-            <a:r>
-              <a:rPr lang="en-US" sz="2000" b="0" i="0" u="none" strike="noStrike" cap="none">
-                <a:solidFill>
-                  <a:srgbClr val="000000"/>
-                </a:solidFill>
-                <a:latin typeface="Open Sans"/>
-                <a:ea typeface="Open Sans"/>
-                <a:cs typeface="Open Sans"/>
-                <a:sym typeface="Open Sans"/>
-              </a:rPr>
-              <a:t>” crises</a:t>
-            </a:r>
-            <a:endParaRPr lang="en-US" sz="2000" b="0" i="0" u="none" strike="noStrike" cap="none" dirty="0">
-              <a:solidFill>
-                <a:srgbClr val="000000"/>
-              </a:solidFill>
-              <a:latin typeface="Open Sans"/>
-              <a:ea typeface="Open Sans"/>
-              <a:cs typeface="Open Sans"/>
-              <a:sym typeface="Open Sans"/>
-            </a:endParaRPr>
           </a:p>
           <a:p>
             <a:pPr marL="457200" marR="0" lvl="0" indent="-355600" algn="l" rtl="0">
@@ -28124,23 +29237,8 @@
                 <a:cs typeface="Open Sans"/>
                 <a:sym typeface="Open Sans"/>
               </a:rPr>
-              <a:t>Be prepared to share your summary with the class in about 30 minutes</a:t>
+              <a:t>Be prepared to share your summary with the class</a:t>
             </a:r>
-          </a:p>
-          <a:p>
-            <a:pPr marL="457200" lvl="0" indent="-355600" algn="l" rtl="0">
-              <a:lnSpc>
-                <a:spcPct val="115000"/>
-              </a:lnSpc>
-              <a:spcBef>
-                <a:spcPts val="0"/>
-              </a:spcBef>
-              <a:spcAft>
-                <a:spcPts val="0"/>
-              </a:spcAft>
-              <a:buSzPts val="2000"/>
-              <a:buChar char="●"/>
-            </a:pPr>
             <a:endParaRPr sz="2000" dirty="0"/>
           </a:p>
         </p:txBody>
@@ -28153,7 +29251,7 @@
 </p:sld>
 </file>
 
-<file path=ppt/slides/slide22.xml><?xml version="1.0" encoding="utf-8"?>
+<file path=ppt/slides/slide26.xml><?xml version="1.0" encoding="utf-8"?>
 <p:sld xmlns:a="http://schemas.openxmlformats.org/drawingml/2006/main" xmlns:r="http://schemas.openxmlformats.org/officeDocument/2006/relationships" xmlns:p="http://schemas.openxmlformats.org/presentationml/2006/main">
   <p:cSld>
     <p:spTree>
@@ -28213,7 +29311,7 @@
           <p:nvPr/>
         </p:nvPicPr>
         <p:blipFill>
-          <a:blip r:embed="rId2">
+          <a:blip r:embed="rId3">
             <a:extLst>
               <a:ext uri="{28A0092B-C50C-407E-A947-70E740481C1C}">
                 <a14:useLocalDpi xmlns:a14="http://schemas.microsoft.com/office/drawing/2010/main" val="0"/>
@@ -28247,7 +29345,7 @@
 </p:sld>
 </file>
 
-<file path=ppt/slides/slide23.xml><?xml version="1.0" encoding="utf-8"?>
+<file path=ppt/slides/slide27.xml><?xml version="1.0" encoding="utf-8"?>
 <p:sld xmlns:a="http://schemas.openxmlformats.org/drawingml/2006/main" xmlns:r="http://schemas.openxmlformats.org/officeDocument/2006/relationships" xmlns:p="http://schemas.openxmlformats.org/presentationml/2006/main">
   <p:cSld>
     <p:spTree>
@@ -28269,7 +29367,7 @@
           <p:cNvPr id="2" name="Title 1">
             <a:extLst>
               <a:ext uri="{FF2B5EF4-FFF2-40B4-BE49-F238E27FC236}">
-                <a16:creationId xmlns:a16="http://schemas.microsoft.com/office/drawing/2014/main" id="{74D13D08-A8EF-4B8F-A0F3-907B16C85AD4}"/>
+                <a16:creationId xmlns:a16="http://schemas.microsoft.com/office/drawing/2014/main" id="{680422EA-5513-0D02-439A-D882C89F1C22}"/>
               </a:ext>
             </a:extLst>
           </p:cNvPr>
@@ -28287,7 +29385,7 @@
           <a:p>
             <a:r>
               <a:rPr lang="en-US" dirty="0"/>
-              <a:t>Background</a:t>
+              <a:t>Discussion Questions</a:t>
             </a:r>
           </a:p>
         </p:txBody>
@@ -28297,7 +29395,7 @@
           <p:cNvPr id="3" name="Text Placeholder 2">
             <a:extLst>
               <a:ext uri="{FF2B5EF4-FFF2-40B4-BE49-F238E27FC236}">
-                <a16:creationId xmlns:a16="http://schemas.microsoft.com/office/drawing/2014/main" id="{0CF28CCD-B8D0-48BE-97E1-4ED32D2B17CB}"/>
+                <a16:creationId xmlns:a16="http://schemas.microsoft.com/office/drawing/2014/main" id="{92D8635C-B24D-DE9B-2BC1-3C516F4231F9}"/>
               </a:ext>
             </a:extLst>
           </p:cNvPr>
@@ -28310,41 +29408,132 @@
         </p:nvSpPr>
         <p:spPr/>
         <p:txBody>
-          <a:bodyPr/>
+          <a:bodyPr>
+            <a:normAutofit/>
+          </a:bodyPr>
           <a:lstStyle/>
           <a:p>
             <a:r>
               <a:rPr lang="en-US" dirty="0"/>
-              <a:t>Each blow costs the Oil and Gas industry a Billion dollars</a:t>
+              <a:t>How mitigate risk in Oil spill and </a:t>
+            </a:r>
+            <a:r>
+              <a:rPr lang="en-US" dirty="0">
+                <a:solidFill>
+                  <a:srgbClr val="000000"/>
+                </a:solidFill>
+              </a:rPr>
+              <a:t>solve the “Oil Spill” crises</a:t>
+            </a:r>
+            <a:r>
+              <a:rPr lang="en-US" dirty="0"/>
+              <a:t> using big data?</a:t>
+            </a:r>
+          </a:p>
+          <a:p>
+            <a:pPr indent="-285750">
+              <a:spcBef>
+                <a:spcPts val="0"/>
+              </a:spcBef>
+              <a:buFont typeface="Courier New" panose="02070309020205020404" pitchFamily="49" charset="0"/>
+              <a:buChar char="o"/>
+            </a:pPr>
+            <a:r>
+              <a:rPr lang="en-US" dirty="0"/>
+              <a:t>Each blow costs the Oil and Gas industry a Billion dollars? Can we avoid it? Can we see it coming and take action? </a:t>
+            </a:r>
+          </a:p>
+          <a:p>
+            <a:pPr indent="-285750">
+              <a:spcBef>
+                <a:spcPts val="0"/>
+              </a:spcBef>
+              <a:buFont typeface="Courier New" panose="02070309020205020404" pitchFamily="49" charset="0"/>
+              <a:buChar char="o"/>
+            </a:pPr>
+            <a:r>
+              <a:rPr lang="en-US" dirty="0"/>
+              <a:t>Each operating rig consists of thousands of sensors ? Sensor data can be used to analyze and reduce HSE (Health, Safety and Environment) risk considerably, how to store and make computation?</a:t>
             </a:r>
           </a:p>
           <a:p>
             <a:r>
               <a:rPr lang="en-US" dirty="0"/>
-              <a:t>Can we avoid it? Can we see it coming and take action? </a:t>
+              <a:t>How to explore and communicate data analytics to the stakeholders?</a:t>
             </a:r>
           </a:p>
           <a:p>
+            <a:pPr marL="514350" indent="-285750">
+              <a:buFont typeface="Courier New" panose="02070309020205020404" pitchFamily="49" charset="0"/>
+              <a:buChar char="o"/>
+            </a:pPr>
             <a:r>
               <a:rPr lang="en-US" dirty="0"/>
-              <a:t>Each operating rig consists of thousands of sensors </a:t>
+              <a:t>What data exploration and visualization to use for time-series data?</a:t>
             </a:r>
           </a:p>
           <a:p>
+            <a:pPr marL="514350" indent="-285750">
+              <a:buFont typeface="Courier New" panose="02070309020205020404" pitchFamily="49" charset="0"/>
+              <a:buChar char="o"/>
+            </a:pPr>
             <a:r>
               <a:rPr lang="en-US" dirty="0"/>
-              <a:t>Sensor data can be used to analyze and reduce HSE (Health, Safety and Environment) risk considerably</a:t>
+              <a:t>What are the top metrics you can think about?</a:t>
             </a:r>
+          </a:p>
+          <a:p>
+            <a:pPr marL="514350" indent="-285750">
+              <a:buFont typeface="Courier New" panose="02070309020205020404" pitchFamily="49" charset="0"/>
+              <a:buChar char="o"/>
+            </a:pPr>
+            <a:r>
+              <a:rPr lang="en-US" dirty="0"/>
+              <a:t>If using the dashboard below, try to communicate the result to the stakeholders. </a:t>
+            </a:r>
+          </a:p>
+          <a:p>
+            <a:endParaRPr lang="en-US" dirty="0"/>
           </a:p>
           <a:p>
             <a:endParaRPr lang="en-US" dirty="0"/>
           </a:p>
         </p:txBody>
       </p:sp>
+      <p:pic>
+        <p:nvPicPr>
+          <p:cNvPr id="6" name="Picture 5" descr="Application&#10;&#10;Description automatically generated with medium confidence">
+            <a:extLst>
+              <a:ext uri="{FF2B5EF4-FFF2-40B4-BE49-F238E27FC236}">
+                <a16:creationId xmlns:a16="http://schemas.microsoft.com/office/drawing/2014/main" id="{14011870-E1A2-C5AE-E9AE-2AC295AFEC5E}"/>
+              </a:ext>
+            </a:extLst>
+          </p:cNvPr>
+          <p:cNvPicPr>
+            <a:picLocks noChangeAspect="1"/>
+          </p:cNvPicPr>
+          <p:nvPr/>
+        </p:nvPicPr>
+        <p:blipFill>
+          <a:blip r:embed="rId3"/>
+          <a:stretch>
+            <a:fillRect/>
+          </a:stretch>
+        </p:blipFill>
+        <p:spPr>
+          <a:xfrm>
+            <a:off x="993932" y="4645663"/>
+            <a:ext cx="6010372" cy="2040363"/>
+          </a:xfrm>
+          <a:prstGeom prst="rect">
+            <a:avLst/>
+          </a:prstGeom>
+        </p:spPr>
+      </p:pic>
     </p:spTree>
     <p:extLst>
       <p:ext uri="{BB962C8B-B14F-4D97-AF65-F5344CB8AC3E}">
-        <p14:creationId xmlns:p14="http://schemas.microsoft.com/office/powerpoint/2010/main" val="74952263"/>
+        <p14:creationId xmlns:p14="http://schemas.microsoft.com/office/powerpoint/2010/main" val="3394103434"/>
       </p:ext>
     </p:extLst>
   </p:cSld>
@@ -28354,7 +29543,7 @@
 </p:sld>
 </file>
 
-<file path=ppt/slides/slide24.xml><?xml version="1.0" encoding="utf-8"?>
+<file path=ppt/slides/slide28.xml><?xml version="1.0" encoding="utf-8"?>
 <p:sld xmlns:a="http://schemas.openxmlformats.org/drawingml/2006/main" xmlns:r="http://schemas.openxmlformats.org/officeDocument/2006/relationships" xmlns:p="http://schemas.openxmlformats.org/presentationml/2006/main">
   <p:cSld>
     <p:spTree>
@@ -28442,12 +29631,12 @@
 </p:sld>
 </file>
 
-<file path=ppt/slides/slide25.xml><?xml version="1.0" encoding="utf-8"?>
+<file path=ppt/slides/slide29.xml><?xml version="1.0" encoding="utf-8"?>
 <p:sld xmlns:a="http://schemas.openxmlformats.org/drawingml/2006/main" xmlns:r="http://schemas.openxmlformats.org/officeDocument/2006/relationships" xmlns:p="http://schemas.openxmlformats.org/presentationml/2006/main">
   <p:cSld>
     <p:spTree>
       <p:nvGrpSpPr>
-        <p:cNvPr id="1" name="Shape 137"/>
+        <p:cNvPr id="1" name=""/>
         <p:cNvGrpSpPr/>
         <p:nvPr/>
       </p:nvGrpSpPr>
@@ -28461,164 +29650,65 @@
       </p:grpSpPr>
       <p:sp>
         <p:nvSpPr>
-          <p:cNvPr id="138" name="Google Shape;138;p34"/>
-          <p:cNvSpPr txBox="1"/>
-          <p:nvPr/>
+          <p:cNvPr id="3" name="Text Placeholder 2">
+            <a:extLst>
+              <a:ext uri="{FF2B5EF4-FFF2-40B4-BE49-F238E27FC236}">
+                <a16:creationId xmlns:a16="http://schemas.microsoft.com/office/drawing/2014/main" id="{EAD396BB-1168-FB64-5174-C08D1A9FA39D}"/>
+              </a:ext>
+            </a:extLst>
+          </p:cNvPr>
+          <p:cNvSpPr>
+            <a:spLocks noGrp="1"/>
+          </p:cNvSpPr>
+          <p:nvPr>
+            <p:ph type="body" idx="1"/>
+          </p:nvPr>
         </p:nvSpPr>
-        <p:spPr>
-          <a:xfrm>
-            <a:off x="453007" y="171975"/>
-            <a:ext cx="8212800" cy="885000"/>
-          </a:xfrm>
-          <a:prstGeom prst="rect">
-            <a:avLst/>
-          </a:prstGeom>
-          <a:noFill/>
-          <a:ln>
-            <a:noFill/>
-          </a:ln>
-        </p:spPr>
+        <p:spPr/>
         <p:txBody>
-          <a:bodyPr spcFirstLastPara="1" wrap="square" lIns="91425" tIns="45700" rIns="91425" bIns="45700" anchor="ctr" anchorCtr="0">
-            <a:normAutofit/>
-          </a:bodyPr>
+          <a:bodyPr/>
           <a:lstStyle/>
           <a:p>
-            <a:pPr marL="0" marR="0" lvl="0" indent="0" algn="l" rtl="0">
-              <a:lnSpc>
-                <a:spcPct val="90000"/>
-              </a:lnSpc>
-              <a:spcBef>
-                <a:spcPts val="0"/>
-              </a:spcBef>
-              <a:spcAft>
-                <a:spcPts val="0"/>
-              </a:spcAft>
-              <a:buClr>
-                <a:srgbClr val="000000"/>
-              </a:buClr>
-              <a:buSzPts val="4200"/>
-              <a:buFont typeface="Arial"/>
-              <a:buNone/>
-            </a:pPr>
-            <a:r>
-              <a:rPr lang="en-US" sz="4200" b="0" i="0" u="none" strike="noStrike" cap="none">
-                <a:solidFill>
-                  <a:srgbClr val="0064A4"/>
-                </a:solidFill>
-                <a:latin typeface="Economica"/>
-                <a:ea typeface="Economica"/>
-                <a:cs typeface="Economica"/>
-                <a:sym typeface="Economica"/>
-              </a:rPr>
-              <a:t>Q&amp;A</a:t>
-            </a:r>
-            <a:endParaRPr sz="4200" b="0" i="0" u="none" strike="noStrike" cap="none">
-              <a:solidFill>
-                <a:srgbClr val="0064A4"/>
-              </a:solidFill>
-              <a:latin typeface="Economica"/>
-              <a:ea typeface="Economica"/>
-              <a:cs typeface="Economica"/>
-              <a:sym typeface="Economica"/>
-            </a:endParaRPr>
-          </a:p>
-        </p:txBody>
-      </p:sp>
-      <p:sp>
-        <p:nvSpPr>
-          <p:cNvPr id="139" name="Google Shape;139;p34"/>
-          <p:cNvSpPr txBox="1"/>
-          <p:nvPr/>
-        </p:nvSpPr>
-        <p:spPr>
-          <a:xfrm>
-            <a:off x="453000" y="1323026"/>
-            <a:ext cx="3441000" cy="5069400"/>
-          </a:xfrm>
-          <a:prstGeom prst="rect">
-            <a:avLst/>
-          </a:prstGeom>
-          <a:noFill/>
-          <a:ln>
-            <a:noFill/>
-          </a:ln>
-        </p:spPr>
-        <p:txBody>
-          <a:bodyPr spcFirstLastPara="1" wrap="square" lIns="91425" tIns="45700" rIns="91425" bIns="45700" anchor="t" anchorCtr="0">
-            <a:normAutofit/>
-          </a:bodyPr>
-          <a:lstStyle/>
-          <a:p>
-            <a:pPr marL="0" marR="0" lvl="0" indent="0" algn="l" rtl="0">
-              <a:lnSpc>
-                <a:spcPct val="90000"/>
-              </a:lnSpc>
-              <a:spcBef>
-                <a:spcPts val="1000"/>
-              </a:spcBef>
-              <a:spcAft>
-                <a:spcPts val="0"/>
-              </a:spcAft>
-              <a:buClr>
-                <a:srgbClr val="000000"/>
-              </a:buClr>
-              <a:buSzPts val="2000"/>
-              <a:buFont typeface="Arial"/>
-              <a:buNone/>
-            </a:pPr>
-            <a:r>
-              <a:rPr lang="en-US" sz="2000" b="0" i="0" u="none" strike="noStrike" cap="none">
-                <a:solidFill>
-                  <a:srgbClr val="000000"/>
-                </a:solidFill>
-                <a:latin typeface="Open Sans"/>
-                <a:ea typeface="Open Sans"/>
-                <a:cs typeface="Open Sans"/>
-                <a:sym typeface="Open Sans"/>
-              </a:rPr>
-              <a:t>What questions and comments do you have?</a:t>
-            </a:r>
-            <a:endParaRPr sz="2000" b="0" i="0" u="none" strike="noStrike" cap="none">
-              <a:solidFill>
-                <a:srgbClr val="000000"/>
-              </a:solidFill>
-              <a:latin typeface="Open Sans"/>
-              <a:ea typeface="Open Sans"/>
-              <a:cs typeface="Open Sans"/>
-              <a:sym typeface="Open Sans"/>
-            </a:endParaRPr>
+            <a:endParaRPr lang="en-US"/>
           </a:p>
         </p:txBody>
       </p:sp>
       <p:pic>
         <p:nvPicPr>
-          <p:cNvPr id="140" name="Google Shape;140;p34"/>
-          <p:cNvPicPr preferRelativeResize="0"/>
+          <p:cNvPr id="5" name="Picture 4" descr="Graphical user interface, application&#10;&#10;Description automatically generated">
+            <a:extLst>
+              <a:ext uri="{FF2B5EF4-FFF2-40B4-BE49-F238E27FC236}">
+                <a16:creationId xmlns:a16="http://schemas.microsoft.com/office/drawing/2014/main" id="{3C6D0946-EF19-10E6-2BC7-51C6E14402B4}"/>
+              </a:ext>
+            </a:extLst>
+          </p:cNvPr>
+          <p:cNvPicPr>
+            <a:picLocks noChangeAspect="1"/>
+          </p:cNvPicPr>
           <p:nvPr/>
         </p:nvPicPr>
-        <p:blipFill rotWithShape="1">
-          <a:blip r:embed="rId3">
-            <a:alphaModFix/>
-          </a:blip>
-          <a:srcRect/>
-          <a:stretch/>
+        <p:blipFill>
+          <a:blip r:embed="rId3"/>
+          <a:stretch>
+            <a:fillRect/>
+          </a:stretch>
         </p:blipFill>
         <p:spPr>
           <a:xfrm>
-            <a:off x="3914796" y="1590414"/>
-            <a:ext cx="4278656" cy="4424998"/>
+            <a:off x="0" y="538416"/>
+            <a:ext cx="9144000" cy="5781167"/>
           </a:xfrm>
           <a:prstGeom prst="rect">
             <a:avLst/>
           </a:prstGeom>
-          <a:noFill/>
-          <a:ln>
-            <a:noFill/>
-          </a:ln>
         </p:spPr>
       </p:pic>
     </p:spTree>
+    <p:extLst>
+      <p:ext uri="{BB962C8B-B14F-4D97-AF65-F5344CB8AC3E}">
+        <p14:creationId xmlns:p14="http://schemas.microsoft.com/office/powerpoint/2010/main" val="1082174433"/>
+      </p:ext>
+    </p:extLst>
   </p:cSld>
   <p:clrMapOvr>
     <a:masterClrMapping/>
@@ -28867,6 +29957,190 @@
           </a:p>
         </p:txBody>
       </p:sp>
+    </p:spTree>
+  </p:cSld>
+  <p:clrMapOvr>
+    <a:masterClrMapping/>
+  </p:clrMapOvr>
+</p:sld>
+</file>
+
+<file path=ppt/slides/slide30.xml><?xml version="1.0" encoding="utf-8"?>
+<p:sld xmlns:a="http://schemas.openxmlformats.org/drawingml/2006/main" xmlns:r="http://schemas.openxmlformats.org/officeDocument/2006/relationships" xmlns:p="http://schemas.openxmlformats.org/presentationml/2006/main">
+  <p:cSld>
+    <p:spTree>
+      <p:nvGrpSpPr>
+        <p:cNvPr id="1" name="Shape 137"/>
+        <p:cNvGrpSpPr/>
+        <p:nvPr/>
+      </p:nvGrpSpPr>
+      <p:grpSpPr>
+        <a:xfrm>
+          <a:off x="0" y="0"/>
+          <a:ext cx="0" cy="0"/>
+          <a:chOff x="0" y="0"/>
+          <a:chExt cx="0" cy="0"/>
+        </a:xfrm>
+      </p:grpSpPr>
+      <p:sp>
+        <p:nvSpPr>
+          <p:cNvPr id="138" name="Google Shape;138;p34"/>
+          <p:cNvSpPr txBox="1"/>
+          <p:nvPr/>
+        </p:nvSpPr>
+        <p:spPr>
+          <a:xfrm>
+            <a:off x="453007" y="171975"/>
+            <a:ext cx="8212800" cy="885000"/>
+          </a:xfrm>
+          <a:prstGeom prst="rect">
+            <a:avLst/>
+          </a:prstGeom>
+          <a:noFill/>
+          <a:ln>
+            <a:noFill/>
+          </a:ln>
+        </p:spPr>
+        <p:txBody>
+          <a:bodyPr spcFirstLastPara="1" wrap="square" lIns="91425" tIns="45700" rIns="91425" bIns="45700" anchor="ctr" anchorCtr="0">
+            <a:normAutofit/>
+          </a:bodyPr>
+          <a:lstStyle/>
+          <a:p>
+            <a:pPr marL="0" marR="0" lvl="0" indent="0" algn="l" rtl="0">
+              <a:lnSpc>
+                <a:spcPct val="90000"/>
+              </a:lnSpc>
+              <a:spcBef>
+                <a:spcPts val="0"/>
+              </a:spcBef>
+              <a:spcAft>
+                <a:spcPts val="0"/>
+              </a:spcAft>
+              <a:buClr>
+                <a:srgbClr val="000000"/>
+              </a:buClr>
+              <a:buSzPts val="4200"/>
+              <a:buFont typeface="Arial"/>
+              <a:buNone/>
+            </a:pPr>
+            <a:r>
+              <a:rPr lang="en-US" sz="4200" b="0" i="0" u="none" strike="noStrike" cap="none">
+                <a:solidFill>
+                  <a:srgbClr val="0064A4"/>
+                </a:solidFill>
+                <a:latin typeface="Economica"/>
+                <a:ea typeface="Economica"/>
+                <a:cs typeface="Economica"/>
+                <a:sym typeface="Economica"/>
+              </a:rPr>
+              <a:t>Q&amp;A</a:t>
+            </a:r>
+            <a:endParaRPr sz="4200" b="0" i="0" u="none" strike="noStrike" cap="none">
+              <a:solidFill>
+                <a:srgbClr val="0064A4"/>
+              </a:solidFill>
+              <a:latin typeface="Economica"/>
+              <a:ea typeface="Economica"/>
+              <a:cs typeface="Economica"/>
+              <a:sym typeface="Economica"/>
+            </a:endParaRPr>
+          </a:p>
+        </p:txBody>
+      </p:sp>
+      <p:sp>
+        <p:nvSpPr>
+          <p:cNvPr id="139" name="Google Shape;139;p34"/>
+          <p:cNvSpPr txBox="1"/>
+          <p:nvPr/>
+        </p:nvSpPr>
+        <p:spPr>
+          <a:xfrm>
+            <a:off x="453000" y="1323026"/>
+            <a:ext cx="3441000" cy="5069400"/>
+          </a:xfrm>
+          <a:prstGeom prst="rect">
+            <a:avLst/>
+          </a:prstGeom>
+          <a:noFill/>
+          <a:ln>
+            <a:noFill/>
+          </a:ln>
+        </p:spPr>
+        <p:txBody>
+          <a:bodyPr spcFirstLastPara="1" wrap="square" lIns="91425" tIns="45700" rIns="91425" bIns="45700" anchor="t" anchorCtr="0">
+            <a:normAutofit/>
+          </a:bodyPr>
+          <a:lstStyle/>
+          <a:p>
+            <a:pPr marL="0" marR="0" lvl="0" indent="0" algn="l" rtl="0">
+              <a:lnSpc>
+                <a:spcPct val="90000"/>
+              </a:lnSpc>
+              <a:spcBef>
+                <a:spcPts val="1000"/>
+              </a:spcBef>
+              <a:spcAft>
+                <a:spcPts val="0"/>
+              </a:spcAft>
+              <a:buClr>
+                <a:srgbClr val="000000"/>
+              </a:buClr>
+              <a:buSzPts val="2000"/>
+              <a:buFont typeface="Arial"/>
+              <a:buNone/>
+            </a:pPr>
+            <a:r>
+              <a:rPr lang="en-US" sz="2000" b="0" i="0" u="none" strike="noStrike" cap="none">
+                <a:solidFill>
+                  <a:srgbClr val="000000"/>
+                </a:solidFill>
+                <a:latin typeface="Open Sans"/>
+                <a:ea typeface="Open Sans"/>
+                <a:cs typeface="Open Sans"/>
+                <a:sym typeface="Open Sans"/>
+              </a:rPr>
+              <a:t>What questions and comments do you have?</a:t>
+            </a:r>
+            <a:endParaRPr sz="2000" b="0" i="0" u="none" strike="noStrike" cap="none">
+              <a:solidFill>
+                <a:srgbClr val="000000"/>
+              </a:solidFill>
+              <a:latin typeface="Open Sans"/>
+              <a:ea typeface="Open Sans"/>
+              <a:cs typeface="Open Sans"/>
+              <a:sym typeface="Open Sans"/>
+            </a:endParaRPr>
+          </a:p>
+        </p:txBody>
+      </p:sp>
+      <p:pic>
+        <p:nvPicPr>
+          <p:cNvPr id="140" name="Google Shape;140;p34"/>
+          <p:cNvPicPr preferRelativeResize="0"/>
+          <p:nvPr/>
+        </p:nvPicPr>
+        <p:blipFill rotWithShape="1">
+          <a:blip r:embed="rId3">
+            <a:alphaModFix/>
+          </a:blip>
+          <a:srcRect/>
+          <a:stretch/>
+        </p:blipFill>
+        <p:spPr>
+          <a:xfrm>
+            <a:off x="3914796" y="1590414"/>
+            <a:ext cx="4278656" cy="4424998"/>
+          </a:xfrm>
+          <a:prstGeom prst="rect">
+            <a:avLst/>
+          </a:prstGeom>
+          <a:noFill/>
+          <a:ln>
+            <a:noFill/>
+          </a:ln>
+        </p:spPr>
+      </p:pic>
     </p:spTree>
   </p:cSld>
   <p:clrMapOvr>
@@ -30184,7 +31458,7 @@
 </file>
 
 <file path=ppt/slides/slide6.xml><?xml version="1.0" encoding="utf-8"?>
-<p:sld xmlns:a="http://schemas.openxmlformats.org/drawingml/2006/main" xmlns:r="http://schemas.openxmlformats.org/officeDocument/2006/relationships" xmlns:p="http://schemas.openxmlformats.org/presentationml/2006/main" show="0">
+<p:sld xmlns:a="http://schemas.openxmlformats.org/drawingml/2006/main" xmlns:r="http://schemas.openxmlformats.org/officeDocument/2006/relationships" xmlns:p="http://schemas.openxmlformats.org/presentationml/2006/main">
   <p:cSld>
     <p:spTree>
       <p:nvGrpSpPr>
@@ -32079,7 +33353,7 @@
   <p:cSld>
     <p:spTree>
       <p:nvGrpSpPr>
-        <p:cNvPr id="1" name="Shape 109"/>
+        <p:cNvPr id="1" name=""/>
         <p:cNvGrpSpPr/>
         <p:nvPr/>
       </p:nvGrpSpPr>
@@ -32093,305 +33367,68 @@
       </p:grpSpPr>
       <p:sp>
         <p:nvSpPr>
-          <p:cNvPr id="110" name="Google Shape;110;g10a5157cc27_0_0"/>
-          <p:cNvSpPr txBox="1">
+          <p:cNvPr id="2" name="Title 1">
+            <a:extLst>
+              <a:ext uri="{FF2B5EF4-FFF2-40B4-BE49-F238E27FC236}">
+                <a16:creationId xmlns:a16="http://schemas.microsoft.com/office/drawing/2014/main" id="{07E53DD4-2AB1-505E-8000-C098A1315EDC}"/>
+              </a:ext>
+            </a:extLst>
+          </p:cNvPr>
+          <p:cNvSpPr>
             <a:spLocks noGrp="1"/>
           </p:cNvSpPr>
           <p:nvPr>
             <p:ph type="title"/>
           </p:nvPr>
         </p:nvSpPr>
+        <p:spPr/>
+        <p:txBody>
+          <a:bodyPr/>
+          <a:lstStyle/>
+          <a:p>
+            <a:r>
+              <a:rPr lang="en-US" dirty="0"/>
+              <a:t>Demo of different ETL pipelines</a:t>
+            </a:r>
+          </a:p>
+        </p:txBody>
+      </p:sp>
+      <p:pic>
+        <p:nvPicPr>
+          <p:cNvPr id="12" name="Picture 11" descr="Diagram&#10;&#10;Description automatically generated">
+            <a:extLst>
+              <a:ext uri="{FF2B5EF4-FFF2-40B4-BE49-F238E27FC236}">
+                <a16:creationId xmlns:a16="http://schemas.microsoft.com/office/drawing/2014/main" id="{F423C6CE-F7E0-2B7E-C071-D9FB0744F79D}"/>
+              </a:ext>
+            </a:extLst>
+          </p:cNvPr>
+          <p:cNvPicPr>
+            <a:picLocks noChangeAspect="1"/>
+          </p:cNvPicPr>
+          <p:nvPr/>
+        </p:nvPicPr>
+        <p:blipFill>
+          <a:blip r:embed="rId2"/>
+          <a:stretch>
+            <a:fillRect/>
+          </a:stretch>
+        </p:blipFill>
         <p:spPr>
           <a:xfrm>
-            <a:off x="453007" y="171974"/>
-            <a:ext cx="8493900" cy="885000"/>
+            <a:off x="356616" y="1417221"/>
+            <a:ext cx="4705161" cy="2907891"/>
           </a:xfrm>
           <a:prstGeom prst="rect">
             <a:avLst/>
           </a:prstGeom>
         </p:spPr>
-        <p:txBody>
-          <a:bodyPr spcFirstLastPara="1" wrap="square" lIns="91425" tIns="45700" rIns="91425" bIns="45700" anchor="ctr" anchorCtr="0">
-            <a:normAutofit/>
-          </a:bodyPr>
-          <a:lstStyle/>
-          <a:p>
-            <a:pPr marL="0" lvl="0" indent="0" algn="l" rtl="0">
-              <a:spcBef>
-                <a:spcPts val="0"/>
-              </a:spcBef>
-              <a:spcAft>
-                <a:spcPts val="0"/>
-              </a:spcAft>
-              <a:buNone/>
-            </a:pPr>
-            <a:r>
-              <a:rPr lang="en-US" b="0"/>
-              <a:t>Data Visualization</a:t>
-            </a:r>
-            <a:endParaRPr b="0"/>
-          </a:p>
-        </p:txBody>
-      </p:sp>
-      <p:sp>
-        <p:nvSpPr>
-          <p:cNvPr id="111" name="Google Shape;111;g10a5157cc27_0_0"/>
-          <p:cNvSpPr txBox="1">
-            <a:spLocks noGrp="1"/>
-          </p:cNvSpPr>
-          <p:nvPr>
-            <p:ph type="body" idx="1"/>
-          </p:nvPr>
-        </p:nvSpPr>
-        <p:spPr>
-          <a:xfrm>
-            <a:off x="453006" y="1157681"/>
-            <a:ext cx="8493900" cy="5234700"/>
-          </a:xfrm>
-          <a:prstGeom prst="rect">
-            <a:avLst/>
-          </a:prstGeom>
-        </p:spPr>
-        <p:txBody>
-          <a:bodyPr spcFirstLastPara="1" wrap="square" lIns="91425" tIns="45700" rIns="91425" bIns="45700" anchor="t" anchorCtr="0">
-            <a:normAutofit/>
-          </a:bodyPr>
-          <a:lstStyle/>
-          <a:p>
-            <a:pPr marL="0" lvl="0" indent="0" algn="l" rtl="0">
-              <a:lnSpc>
-                <a:spcPct val="113000"/>
-              </a:lnSpc>
-              <a:spcBef>
-                <a:spcPts val="0"/>
-              </a:spcBef>
-              <a:spcAft>
-                <a:spcPts val="0"/>
-              </a:spcAft>
-              <a:buClr>
-                <a:schemeClr val="dk1"/>
-              </a:buClr>
-              <a:buSzPts val="1100"/>
-              <a:buFont typeface="Arial"/>
-              <a:buNone/>
-            </a:pPr>
-            <a:r>
-              <a:rPr lang="en-US" sz="2000"/>
-              <a:t>Here are a set of simple steps for selecting appropriate data visualization:</a:t>
-            </a:r>
-            <a:endParaRPr sz="2000"/>
-          </a:p>
-          <a:p>
-            <a:pPr marL="0" lvl="0" indent="0" algn="l" rtl="0">
-              <a:lnSpc>
-                <a:spcPct val="113000"/>
-              </a:lnSpc>
-              <a:spcBef>
-                <a:spcPts val="1200"/>
-              </a:spcBef>
-              <a:spcAft>
-                <a:spcPts val="0"/>
-              </a:spcAft>
-              <a:buClr>
-                <a:schemeClr val="dk1"/>
-              </a:buClr>
-              <a:buSzPts val="1100"/>
-              <a:buFont typeface="Arial"/>
-              <a:buNone/>
-            </a:pPr>
-            <a:r>
-              <a:rPr lang="en-US" sz="2000" b="1"/>
-              <a:t>Step 1:</a:t>
-            </a:r>
-            <a:r>
-              <a:rPr lang="en-US" sz="2000"/>
-              <a:t> Identify your audience.</a:t>
-            </a:r>
-            <a:endParaRPr sz="2000"/>
-          </a:p>
-          <a:p>
-            <a:pPr marL="0" lvl="0" indent="0" algn="l" rtl="0">
-              <a:lnSpc>
-                <a:spcPct val="113000"/>
-              </a:lnSpc>
-              <a:spcBef>
-                <a:spcPts val="1200"/>
-              </a:spcBef>
-              <a:spcAft>
-                <a:spcPts val="0"/>
-              </a:spcAft>
-              <a:buClr>
-                <a:schemeClr val="dk1"/>
-              </a:buClr>
-              <a:buSzPts val="1100"/>
-              <a:buFont typeface="Arial"/>
-              <a:buNone/>
-            </a:pPr>
-            <a:r>
-              <a:rPr lang="en-US" sz="2000" b="1"/>
-              <a:t>Step 2: </a:t>
-            </a:r>
-            <a:r>
-              <a:rPr lang="en-US" sz="2000"/>
-              <a:t>Identify questions to be answered by your visualization.</a:t>
-            </a:r>
-            <a:endParaRPr sz="2000"/>
-          </a:p>
-          <a:p>
-            <a:pPr marL="0" lvl="0" indent="0" algn="l" rtl="0">
-              <a:lnSpc>
-                <a:spcPct val="113000"/>
-              </a:lnSpc>
-              <a:spcBef>
-                <a:spcPts val="1200"/>
-              </a:spcBef>
-              <a:spcAft>
-                <a:spcPts val="0"/>
-              </a:spcAft>
-              <a:buClr>
-                <a:schemeClr val="dk1"/>
-              </a:buClr>
-              <a:buSzPts val="1100"/>
-              <a:buFont typeface="Arial"/>
-              <a:buNone/>
-            </a:pPr>
-            <a:r>
-              <a:rPr lang="en-US" sz="2000" b="1"/>
-              <a:t>Step 3</a:t>
-            </a:r>
-            <a:r>
-              <a:rPr lang="en-US" sz="2000"/>
-              <a:t>: Think of possible constraints or challenges (e.g., budget limitations, the speed at which the study can be completed, or the dependability of your data) and ask the following questions:</a:t>
-            </a:r>
-            <a:endParaRPr sz="2000"/>
-          </a:p>
-          <a:p>
-            <a:pPr marL="457200" lvl="0" indent="-355600" algn="l" rtl="0">
-              <a:lnSpc>
-                <a:spcPct val="113000"/>
-              </a:lnSpc>
-              <a:spcBef>
-                <a:spcPts val="1200"/>
-              </a:spcBef>
-              <a:spcAft>
-                <a:spcPts val="0"/>
-              </a:spcAft>
-              <a:buSzPts val="2000"/>
-              <a:buChar char="●"/>
-            </a:pPr>
-            <a:r>
-              <a:rPr lang="en-US" sz="2000"/>
-              <a:t>Is my data reliable?</a:t>
-            </a:r>
-            <a:endParaRPr sz="2000"/>
-          </a:p>
-          <a:p>
-            <a:pPr marL="457200" lvl="0" indent="-355600" algn="l" rtl="0">
-              <a:lnSpc>
-                <a:spcPct val="113000"/>
-              </a:lnSpc>
-              <a:spcBef>
-                <a:spcPts val="0"/>
-              </a:spcBef>
-              <a:spcAft>
-                <a:spcPts val="0"/>
-              </a:spcAft>
-              <a:buSzPts val="2000"/>
-              <a:buChar char="●"/>
-            </a:pPr>
-            <a:r>
-              <a:rPr lang="en-US" sz="2000"/>
-              <a:t>Is the value of the analysis greater than the cost?</a:t>
-            </a:r>
-            <a:endParaRPr sz="2000"/>
-          </a:p>
-          <a:p>
-            <a:pPr marL="457200" lvl="0" indent="-355600" algn="l" rtl="0">
-              <a:lnSpc>
-                <a:spcPct val="113000"/>
-              </a:lnSpc>
-              <a:spcBef>
-                <a:spcPts val="0"/>
-              </a:spcBef>
-              <a:spcAft>
-                <a:spcPts val="0"/>
-              </a:spcAft>
-              <a:buSzPts val="2000"/>
-              <a:buChar char="●"/>
-            </a:pPr>
-            <a:r>
-              <a:rPr lang="en-US" sz="2000"/>
-              <a:t>How will I store my data?</a:t>
-            </a:r>
-            <a:endParaRPr sz="2000"/>
-          </a:p>
-          <a:p>
-            <a:pPr marL="457200" lvl="0" indent="-355600" algn="l" rtl="0">
-              <a:lnSpc>
-                <a:spcPct val="113000"/>
-              </a:lnSpc>
-              <a:spcBef>
-                <a:spcPts val="0"/>
-              </a:spcBef>
-              <a:spcAft>
-                <a:spcPts val="0"/>
-              </a:spcAft>
-              <a:buSzPts val="2000"/>
-              <a:buChar char="●"/>
-            </a:pPr>
-            <a:r>
-              <a:rPr lang="en-US" sz="2000"/>
-              <a:t>Is the data owned or controlled by someone else?</a:t>
-            </a:r>
-            <a:endParaRPr sz="2000"/>
-          </a:p>
-          <a:p>
-            <a:pPr marL="0" lvl="0" indent="0" algn="l" rtl="0">
-              <a:lnSpc>
-                <a:spcPct val="113000"/>
-              </a:lnSpc>
-              <a:spcBef>
-                <a:spcPts val="1200"/>
-              </a:spcBef>
-              <a:spcAft>
-                <a:spcPts val="0"/>
-              </a:spcAft>
-              <a:buClr>
-                <a:schemeClr val="dk1"/>
-              </a:buClr>
-              <a:buSzPts val="1100"/>
-              <a:buFont typeface="Arial"/>
-              <a:buNone/>
-            </a:pPr>
-            <a:r>
-              <a:rPr lang="en-US" sz="2000" b="1"/>
-              <a:t>Step 4: </a:t>
-            </a:r>
-            <a:r>
-              <a:rPr lang="en-US" sz="2000"/>
-              <a:t>Select the appropriate visualization.</a:t>
-            </a:r>
-            <a:endParaRPr sz="2000">
-              <a:highlight>
-                <a:srgbClr val="FFFF00"/>
-              </a:highlight>
-            </a:endParaRPr>
-          </a:p>
-          <a:p>
-            <a:pPr marL="0" lvl="0" indent="0" algn="l" rtl="0">
-              <a:spcBef>
-                <a:spcPts val="1200"/>
-              </a:spcBef>
-              <a:spcAft>
-                <a:spcPts val="0"/>
-              </a:spcAft>
-              <a:buNone/>
-            </a:pPr>
-            <a:endParaRPr/>
-          </a:p>
-        </p:txBody>
-      </p:sp>
+      </p:pic>
     </p:spTree>
+    <p:extLst>
+      <p:ext uri="{BB962C8B-B14F-4D97-AF65-F5344CB8AC3E}">
+        <p14:creationId xmlns:p14="http://schemas.microsoft.com/office/powerpoint/2010/main" val="1174778065"/>
+      </p:ext>
+    </p:extLst>
   </p:cSld>
   <p:clrMapOvr>
     <a:masterClrMapping/>

</xml_diff>